<commit_message>
Small fixes after QDA lecture
</commit_message>
<xml_diff>
--- a/Lecture slides/NYT B03 - Qualitative Data Analysis.pptx
+++ b/Lecture slides/NYT B03 - Qualitative Data Analysis.pptx
@@ -2532,7 +2532,7 @@
   <p:cSld>
     <p:spTree>
       <p:nvGrpSpPr>
-        <p:cNvPr id="211" name="Shape 211"/>
+        <p:cNvPr id="212" name="Shape 212"/>
         <p:cNvGrpSpPr/>
         <p:nvPr/>
       </p:nvGrpSpPr>
@@ -2546,7 +2546,7 @@
       </p:grpSpPr>
       <p:sp>
         <p:nvSpPr>
-          <p:cNvPr id="212" name="Google Shape;212;g3545e54fe64_0_29:notes"/>
+          <p:cNvPr id="213" name="Google Shape;213;g3545e54fe64_0_29:notes"/>
           <p:cNvSpPr/>
           <p:nvPr>
             <p:ph idx="2" type="sldImg"/>
@@ -2581,7 +2581,7 @@
       </p:sp>
       <p:sp>
         <p:nvSpPr>
-          <p:cNvPr id="213" name="Google Shape;213;g3545e54fe64_0_29:notes"/>
+          <p:cNvPr id="214" name="Google Shape;214;g3545e54fe64_0_29:notes"/>
           <p:cNvSpPr txBox="1"/>
           <p:nvPr>
             <p:ph idx="1" type="body"/>
@@ -2631,7 +2631,7 @@
   <p:cSld>
     <p:spTree>
       <p:nvGrpSpPr>
-        <p:cNvPr id="219" name="Shape 219"/>
+        <p:cNvPr id="220" name="Shape 220"/>
         <p:cNvGrpSpPr/>
         <p:nvPr/>
       </p:nvGrpSpPr>
@@ -2645,7 +2645,7 @@
       </p:grpSpPr>
       <p:sp>
         <p:nvSpPr>
-          <p:cNvPr id="220" name="Google Shape;220;g3574f649a3e_0_55:notes"/>
+          <p:cNvPr id="221" name="Google Shape;221;g3574f649a3e_0_55:notes"/>
           <p:cNvSpPr/>
           <p:nvPr>
             <p:ph idx="2" type="sldImg"/>
@@ -2680,7 +2680,7 @@
       </p:sp>
       <p:sp>
         <p:nvSpPr>
-          <p:cNvPr id="221" name="Google Shape;221;g3574f649a3e_0_55:notes"/>
+          <p:cNvPr id="222" name="Google Shape;222;g3574f649a3e_0_55:notes"/>
           <p:cNvSpPr txBox="1"/>
           <p:nvPr>
             <p:ph idx="1" type="body"/>
@@ -2730,7 +2730,7 @@
   <p:cSld>
     <p:spTree>
       <p:nvGrpSpPr>
-        <p:cNvPr id="228" name="Shape 228"/>
+        <p:cNvPr id="229" name="Shape 229"/>
         <p:cNvGrpSpPr/>
         <p:nvPr/>
       </p:nvGrpSpPr>
@@ -2744,7 +2744,7 @@
       </p:grpSpPr>
       <p:sp>
         <p:nvSpPr>
-          <p:cNvPr id="229" name="Google Shape;229;g2dd50ec92f8_0_0:notes"/>
+          <p:cNvPr id="230" name="Google Shape;230;g2dd50ec92f8_0_0:notes"/>
           <p:cNvSpPr/>
           <p:nvPr>
             <p:ph idx="2" type="sldImg"/>
@@ -2779,7 +2779,7 @@
       </p:sp>
       <p:sp>
         <p:nvSpPr>
-          <p:cNvPr id="230" name="Google Shape;230;g2dd50ec92f8_0_0:notes"/>
+          <p:cNvPr id="231" name="Google Shape;231;g2dd50ec92f8_0_0:notes"/>
           <p:cNvSpPr txBox="1"/>
           <p:nvPr>
             <p:ph idx="1" type="body"/>
@@ -2829,7 +2829,7 @@
   <p:cSld>
     <p:spTree>
       <p:nvGrpSpPr>
-        <p:cNvPr id="235" name="Shape 235"/>
+        <p:cNvPr id="236" name="Shape 236"/>
         <p:cNvGrpSpPr/>
         <p:nvPr/>
       </p:nvGrpSpPr>
@@ -2843,7 +2843,7 @@
       </p:grpSpPr>
       <p:sp>
         <p:nvSpPr>
-          <p:cNvPr id="236" name="Google Shape;236;g3545e54fe64_0_8:notes"/>
+          <p:cNvPr id="237" name="Google Shape;237;g3545e54fe64_0_8:notes"/>
           <p:cNvSpPr/>
           <p:nvPr>
             <p:ph idx="2" type="sldImg"/>
@@ -2878,7 +2878,7 @@
       </p:sp>
       <p:sp>
         <p:nvSpPr>
-          <p:cNvPr id="237" name="Google Shape;237;g3545e54fe64_0_8:notes"/>
+          <p:cNvPr id="238" name="Google Shape;238;g3545e54fe64_0_8:notes"/>
           <p:cNvSpPr txBox="1"/>
           <p:nvPr>
             <p:ph idx="1" type="body"/>
@@ -3027,7 +3027,7 @@
   <p:cSld>
     <p:spTree>
       <p:nvGrpSpPr>
-        <p:cNvPr id="242" name="Shape 242"/>
+        <p:cNvPr id="243" name="Shape 243"/>
         <p:cNvGrpSpPr/>
         <p:nvPr/>
       </p:nvGrpSpPr>
@@ -3041,7 +3041,7 @@
       </p:grpSpPr>
       <p:sp>
         <p:nvSpPr>
-          <p:cNvPr id="243" name="Google Shape;243;g3574f649a3e_0_2:notes"/>
+          <p:cNvPr id="244" name="Google Shape;244;g3574f649a3e_0_2:notes"/>
           <p:cNvSpPr/>
           <p:nvPr>
             <p:ph idx="2" type="sldImg"/>
@@ -3076,7 +3076,7 @@
       </p:sp>
       <p:sp>
         <p:nvSpPr>
-          <p:cNvPr id="244" name="Google Shape;244;g3574f649a3e_0_2:notes"/>
+          <p:cNvPr id="245" name="Google Shape;245;g3574f649a3e_0_2:notes"/>
           <p:cNvSpPr txBox="1"/>
           <p:nvPr>
             <p:ph idx="1" type="body"/>
@@ -3126,7 +3126,7 @@
   <p:cSld>
     <p:spTree>
       <p:nvGrpSpPr>
-        <p:cNvPr id="249" name="Shape 249"/>
+        <p:cNvPr id="250" name="Shape 250"/>
         <p:cNvGrpSpPr/>
         <p:nvPr/>
       </p:nvGrpSpPr>
@@ -3140,7 +3140,7 @@
       </p:grpSpPr>
       <p:sp>
         <p:nvSpPr>
-          <p:cNvPr id="250" name="Google Shape;250;g3545e54fe64_0_113:notes"/>
+          <p:cNvPr id="251" name="Google Shape;251;g3545e54fe64_0_113:notes"/>
           <p:cNvSpPr/>
           <p:nvPr>
             <p:ph idx="2" type="sldImg"/>
@@ -3175,7 +3175,7 @@
       </p:sp>
       <p:sp>
         <p:nvSpPr>
-          <p:cNvPr id="251" name="Google Shape;251;g3545e54fe64_0_113:notes"/>
+          <p:cNvPr id="252" name="Google Shape;252;g3545e54fe64_0_113:notes"/>
           <p:cNvSpPr txBox="1"/>
           <p:nvPr>
             <p:ph idx="1" type="body"/>
@@ -3225,7 +3225,7 @@
   <p:cSld>
     <p:spTree>
       <p:nvGrpSpPr>
-        <p:cNvPr id="255" name="Shape 255"/>
+        <p:cNvPr id="256" name="Shape 256"/>
         <p:cNvGrpSpPr/>
         <p:nvPr/>
       </p:nvGrpSpPr>
@@ -3239,7 +3239,7 @@
       </p:grpSpPr>
       <p:sp>
         <p:nvSpPr>
-          <p:cNvPr id="256" name="Google Shape;256;g124494c3ca9_0_46:notes"/>
+          <p:cNvPr id="257" name="Google Shape;257;g124494c3ca9_0_46:notes"/>
           <p:cNvSpPr/>
           <p:nvPr>
             <p:ph idx="2" type="sldImg"/>
@@ -3274,7 +3274,7 @@
       </p:sp>
       <p:sp>
         <p:nvSpPr>
-          <p:cNvPr id="257" name="Google Shape;257;g124494c3ca9_0_46:notes"/>
+          <p:cNvPr id="258" name="Google Shape;258;g124494c3ca9_0_46:notes"/>
           <p:cNvSpPr txBox="1"/>
           <p:nvPr>
             <p:ph idx="1" type="body"/>
@@ -3324,7 +3324,7 @@
   <p:cSld>
     <p:spTree>
       <p:nvGrpSpPr>
-        <p:cNvPr id="262" name="Shape 262"/>
+        <p:cNvPr id="263" name="Shape 263"/>
         <p:cNvGrpSpPr/>
         <p:nvPr/>
       </p:nvGrpSpPr>
@@ -3338,7 +3338,7 @@
       </p:grpSpPr>
       <p:sp>
         <p:nvSpPr>
-          <p:cNvPr id="263" name="Google Shape;263;g79e2568c9469c685_6:notes"/>
+          <p:cNvPr id="264" name="Google Shape;264;g79e2568c9469c685_6:notes"/>
           <p:cNvSpPr/>
           <p:nvPr>
             <p:ph idx="2" type="sldImg"/>
@@ -3373,7 +3373,7 @@
       </p:sp>
       <p:sp>
         <p:nvSpPr>
-          <p:cNvPr id="264" name="Google Shape;264;g79e2568c9469c685_6:notes"/>
+          <p:cNvPr id="265" name="Google Shape;265;g79e2568c9469c685_6:notes"/>
           <p:cNvSpPr txBox="1"/>
           <p:nvPr>
             <p:ph idx="1" type="body"/>
@@ -3423,7 +3423,7 @@
   <p:cSld>
     <p:spTree>
       <p:nvGrpSpPr>
-        <p:cNvPr id="269" name="Shape 269"/>
+        <p:cNvPr id="270" name="Shape 270"/>
         <p:cNvGrpSpPr/>
         <p:nvPr/>
       </p:nvGrpSpPr>
@@ -3437,7 +3437,7 @@
       </p:grpSpPr>
       <p:sp>
         <p:nvSpPr>
-          <p:cNvPr id="270" name="Google Shape;270;g79e2568c9469c685_0:notes"/>
+          <p:cNvPr id="271" name="Google Shape;271;g79e2568c9469c685_0:notes"/>
           <p:cNvSpPr/>
           <p:nvPr>
             <p:ph idx="2" type="sldImg"/>
@@ -3472,7 +3472,7 @@
       </p:sp>
       <p:sp>
         <p:nvSpPr>
-          <p:cNvPr id="271" name="Google Shape;271;g79e2568c9469c685_0:notes"/>
+          <p:cNvPr id="272" name="Google Shape;272;g79e2568c9469c685_0:notes"/>
           <p:cNvSpPr txBox="1"/>
           <p:nvPr>
             <p:ph idx="1" type="body"/>
@@ -3522,7 +3522,7 @@
   <p:cSld>
     <p:spTree>
       <p:nvGrpSpPr>
-        <p:cNvPr id="276" name="Shape 276"/>
+        <p:cNvPr id="277" name="Shape 277"/>
         <p:cNvGrpSpPr/>
         <p:nvPr/>
       </p:nvGrpSpPr>
@@ -3536,7 +3536,7 @@
       </p:grpSpPr>
       <p:sp>
         <p:nvSpPr>
-          <p:cNvPr id="277" name="Google Shape;277;g3574f649a3e_0_112:notes"/>
+          <p:cNvPr id="278" name="Google Shape;278;g3574f649a3e_0_112:notes"/>
           <p:cNvSpPr/>
           <p:nvPr>
             <p:ph idx="2" type="sldImg"/>
@@ -3571,7 +3571,7 @@
       </p:sp>
       <p:sp>
         <p:nvSpPr>
-          <p:cNvPr id="278" name="Google Shape;278;g3574f649a3e_0_112:notes"/>
+          <p:cNvPr id="279" name="Google Shape;279;g3574f649a3e_0_112:notes"/>
           <p:cNvSpPr txBox="1"/>
           <p:nvPr>
             <p:ph idx="1" type="body"/>
@@ -3621,7 +3621,7 @@
   <p:cSld>
     <p:spTree>
       <p:nvGrpSpPr>
-        <p:cNvPr id="283" name="Shape 283"/>
+        <p:cNvPr id="284" name="Shape 284"/>
         <p:cNvGrpSpPr/>
         <p:nvPr/>
       </p:nvGrpSpPr>
@@ -3635,7 +3635,7 @@
       </p:grpSpPr>
       <p:sp>
         <p:nvSpPr>
-          <p:cNvPr id="284" name="Google Shape;284;g3574f649a3e_0_77:notes"/>
+          <p:cNvPr id="285" name="Google Shape;285;g3574f649a3e_0_77:notes"/>
           <p:cNvSpPr/>
           <p:nvPr>
             <p:ph idx="2" type="sldImg"/>
@@ -3670,7 +3670,7 @@
       </p:sp>
       <p:sp>
         <p:nvSpPr>
-          <p:cNvPr id="285" name="Google Shape;285;g3574f649a3e_0_77:notes"/>
+          <p:cNvPr id="286" name="Google Shape;286;g3574f649a3e_0_77:notes"/>
           <p:cNvSpPr txBox="1"/>
           <p:nvPr>
             <p:ph idx="1" type="body"/>
@@ -3720,7 +3720,7 @@
   <p:cSld>
     <p:spTree>
       <p:nvGrpSpPr>
-        <p:cNvPr id="290" name="Shape 290"/>
+        <p:cNvPr id="291" name="Shape 291"/>
         <p:cNvGrpSpPr/>
         <p:nvPr/>
       </p:nvGrpSpPr>
@@ -3734,7 +3734,7 @@
       </p:grpSpPr>
       <p:sp>
         <p:nvSpPr>
-          <p:cNvPr id="291" name="Google Shape;291;g3574f649a3e_1_0:notes"/>
+          <p:cNvPr id="292" name="Google Shape;292;g3574f649a3e_1_0:notes"/>
           <p:cNvSpPr/>
           <p:nvPr>
             <p:ph idx="2" type="sldImg"/>
@@ -3769,7 +3769,7 @@
       </p:sp>
       <p:sp>
         <p:nvSpPr>
-          <p:cNvPr id="292" name="Google Shape;292;g3574f649a3e_1_0:notes"/>
+          <p:cNvPr id="293" name="Google Shape;293;g3574f649a3e_1_0:notes"/>
           <p:cNvSpPr txBox="1"/>
           <p:nvPr>
             <p:ph idx="1" type="body"/>
@@ -3819,7 +3819,7 @@
   <p:cSld>
     <p:spTree>
       <p:nvGrpSpPr>
-        <p:cNvPr id="297" name="Shape 297"/>
+        <p:cNvPr id="298" name="Shape 298"/>
         <p:cNvGrpSpPr/>
         <p:nvPr/>
       </p:nvGrpSpPr>
@@ -3833,7 +3833,7 @@
       </p:grpSpPr>
       <p:sp>
         <p:nvSpPr>
-          <p:cNvPr id="298" name="Google Shape;298;g3574f649a3e_0_49:notes"/>
+          <p:cNvPr id="299" name="Google Shape;299;g3574f649a3e_0_49:notes"/>
           <p:cNvSpPr/>
           <p:nvPr>
             <p:ph idx="2" type="sldImg"/>
@@ -3868,7 +3868,7 @@
       </p:sp>
       <p:sp>
         <p:nvSpPr>
-          <p:cNvPr id="299" name="Google Shape;299;g3574f649a3e_0_49:notes"/>
+          <p:cNvPr id="300" name="Google Shape;300;g3574f649a3e_0_49:notes"/>
           <p:cNvSpPr txBox="1"/>
           <p:nvPr>
             <p:ph idx="1" type="body"/>
@@ -3918,7 +3918,7 @@
   <p:cSld>
     <p:spTree>
       <p:nvGrpSpPr>
-        <p:cNvPr id="304" name="Shape 304"/>
+        <p:cNvPr id="305" name="Shape 305"/>
         <p:cNvGrpSpPr/>
         <p:nvPr/>
       </p:nvGrpSpPr>
@@ -3932,7 +3932,7 @@
       </p:grpSpPr>
       <p:sp>
         <p:nvSpPr>
-          <p:cNvPr id="305" name="Google Shape;305;g272b046f8d4_0_0:notes"/>
+          <p:cNvPr id="306" name="Google Shape;306;g272b046f8d4_0_0:notes"/>
           <p:cNvSpPr/>
           <p:nvPr>
             <p:ph idx="2" type="sldImg"/>
@@ -3967,7 +3967,7 @@
       </p:sp>
       <p:sp>
         <p:nvSpPr>
-          <p:cNvPr id="306" name="Google Shape;306;g272b046f8d4_0_0:notes"/>
+          <p:cNvPr id="307" name="Google Shape;307;g272b046f8d4_0_0:notes"/>
           <p:cNvSpPr txBox="1"/>
           <p:nvPr>
             <p:ph idx="1" type="body"/>
@@ -4116,7 +4116,7 @@
   <p:cSld>
     <p:spTree>
       <p:nvGrpSpPr>
-        <p:cNvPr id="310" name="Shape 310"/>
+        <p:cNvPr id="311" name="Shape 311"/>
         <p:cNvGrpSpPr/>
         <p:nvPr/>
       </p:nvGrpSpPr>
@@ -4130,7 +4130,7 @@
       </p:grpSpPr>
       <p:sp>
         <p:nvSpPr>
-          <p:cNvPr id="311" name="Google Shape;311;g3574f649a3e_0_124:notes"/>
+          <p:cNvPr id="312" name="Google Shape;312;g3574f649a3e_0_124:notes"/>
           <p:cNvSpPr/>
           <p:nvPr>
             <p:ph idx="2" type="sldImg"/>
@@ -4165,7 +4165,7 @@
       </p:sp>
       <p:sp>
         <p:nvSpPr>
-          <p:cNvPr id="312" name="Google Shape;312;g3574f649a3e_0_124:notes"/>
+          <p:cNvPr id="313" name="Google Shape;313;g3574f649a3e_0_124:notes"/>
           <p:cNvSpPr txBox="1"/>
           <p:nvPr>
             <p:ph idx="1" type="body"/>
@@ -4215,7 +4215,7 @@
   <p:cSld>
     <p:spTree>
       <p:nvGrpSpPr>
-        <p:cNvPr id="318" name="Shape 318"/>
+        <p:cNvPr id="319" name="Shape 319"/>
         <p:cNvGrpSpPr/>
         <p:nvPr/>
       </p:nvGrpSpPr>
@@ -4229,7 +4229,7 @@
       </p:grpSpPr>
       <p:sp>
         <p:nvSpPr>
-          <p:cNvPr id="319" name="Google Shape;319;g3574f649a3e_0_230:notes"/>
+          <p:cNvPr id="320" name="Google Shape;320;g3574f649a3e_0_230:notes"/>
           <p:cNvSpPr/>
           <p:nvPr>
             <p:ph idx="2" type="sldImg"/>
@@ -4264,7 +4264,7 @@
       </p:sp>
       <p:sp>
         <p:nvSpPr>
-          <p:cNvPr id="320" name="Google Shape;320;g3574f649a3e_0_230:notes"/>
+          <p:cNvPr id="321" name="Google Shape;321;g3574f649a3e_0_230:notes"/>
           <p:cNvSpPr txBox="1"/>
           <p:nvPr>
             <p:ph idx="1" type="body"/>
@@ -4314,7 +4314,7 @@
   <p:cSld>
     <p:spTree>
       <p:nvGrpSpPr>
-        <p:cNvPr id="325" name="Shape 325"/>
+        <p:cNvPr id="326" name="Shape 326"/>
         <p:cNvGrpSpPr/>
         <p:nvPr/>
       </p:nvGrpSpPr>
@@ -4328,7 +4328,7 @@
       </p:grpSpPr>
       <p:sp>
         <p:nvSpPr>
-          <p:cNvPr id="326" name="Google Shape;326;g3574f649a3e_1_24:notes"/>
+          <p:cNvPr id="327" name="Google Shape;327;g3574f649a3e_1_24:notes"/>
           <p:cNvSpPr/>
           <p:nvPr>
             <p:ph idx="2" type="sldImg"/>
@@ -4363,7 +4363,7 @@
       </p:sp>
       <p:sp>
         <p:nvSpPr>
-          <p:cNvPr id="327" name="Google Shape;327;g3574f649a3e_1_24:notes"/>
+          <p:cNvPr id="328" name="Google Shape;328;g3574f649a3e_1_24:notes"/>
           <p:cNvSpPr txBox="1"/>
           <p:nvPr>
             <p:ph idx="1" type="body"/>
@@ -4413,7 +4413,7 @@
   <p:cSld>
     <p:spTree>
       <p:nvGrpSpPr>
-        <p:cNvPr id="332" name="Shape 332"/>
+        <p:cNvPr id="333" name="Shape 333"/>
         <p:cNvGrpSpPr/>
         <p:nvPr/>
       </p:nvGrpSpPr>
@@ -4427,7 +4427,7 @@
       </p:grpSpPr>
       <p:sp>
         <p:nvSpPr>
-          <p:cNvPr id="333" name="Google Shape;333;g3574f649a3e_1_18:notes"/>
+          <p:cNvPr id="334" name="Google Shape;334;g3574f649a3e_1_18:notes"/>
           <p:cNvSpPr/>
           <p:nvPr>
             <p:ph idx="2" type="sldImg"/>
@@ -4462,7 +4462,7 @@
       </p:sp>
       <p:sp>
         <p:nvSpPr>
-          <p:cNvPr id="334" name="Google Shape;334;g3574f649a3e_1_18:notes"/>
+          <p:cNvPr id="335" name="Google Shape;335;g3574f649a3e_1_18:notes"/>
           <p:cNvSpPr txBox="1"/>
           <p:nvPr>
             <p:ph idx="1" type="body"/>
@@ -4512,7 +4512,7 @@
   <p:cSld>
     <p:spTree>
       <p:nvGrpSpPr>
-        <p:cNvPr id="339" name="Shape 339"/>
+        <p:cNvPr id="340" name="Shape 340"/>
         <p:cNvGrpSpPr/>
         <p:nvPr/>
       </p:nvGrpSpPr>
@@ -4526,7 +4526,7 @@
       </p:grpSpPr>
       <p:sp>
         <p:nvSpPr>
-          <p:cNvPr id="340" name="Google Shape;340;g3545e54fe64_0_120:notes"/>
+          <p:cNvPr id="341" name="Google Shape;341;g3545e54fe64_0_120:notes"/>
           <p:cNvSpPr/>
           <p:nvPr>
             <p:ph idx="2" type="sldImg"/>
@@ -4561,7 +4561,7 @@
       </p:sp>
       <p:sp>
         <p:nvSpPr>
-          <p:cNvPr id="341" name="Google Shape;341;g3545e54fe64_0_120:notes"/>
+          <p:cNvPr id="342" name="Google Shape;342;g3545e54fe64_0_120:notes"/>
           <p:cNvSpPr txBox="1"/>
           <p:nvPr>
             <p:ph idx="1" type="body"/>
@@ -4611,7 +4611,7 @@
   <p:cSld>
     <p:spTree>
       <p:nvGrpSpPr>
-        <p:cNvPr id="346" name="Shape 346"/>
+        <p:cNvPr id="347" name="Shape 347"/>
         <p:cNvGrpSpPr/>
         <p:nvPr/>
       </p:nvGrpSpPr>
@@ -4625,7 +4625,7 @@
       </p:grpSpPr>
       <p:sp>
         <p:nvSpPr>
-          <p:cNvPr id="347" name="Google Shape;347;g3545e54fe64_0_97:notes"/>
+          <p:cNvPr id="348" name="Google Shape;348;g3545e54fe64_0_97:notes"/>
           <p:cNvSpPr/>
           <p:nvPr>
             <p:ph idx="2" type="sldImg"/>
@@ -4660,7 +4660,7 @@
       </p:sp>
       <p:sp>
         <p:nvSpPr>
-          <p:cNvPr id="348" name="Google Shape;348;g3545e54fe64_0_97:notes"/>
+          <p:cNvPr id="349" name="Google Shape;349;g3545e54fe64_0_97:notes"/>
           <p:cNvSpPr txBox="1"/>
           <p:nvPr>
             <p:ph idx="1" type="body"/>
@@ -4710,7 +4710,7 @@
   <p:cSld>
     <p:spTree>
       <p:nvGrpSpPr>
-        <p:cNvPr id="354" name="Shape 354"/>
+        <p:cNvPr id="355" name="Shape 355"/>
         <p:cNvGrpSpPr/>
         <p:nvPr/>
       </p:nvGrpSpPr>
@@ -4724,7 +4724,7 @@
       </p:grpSpPr>
       <p:sp>
         <p:nvSpPr>
-          <p:cNvPr id="355" name="Google Shape;355;g3545e54fe64_0_91:notes"/>
+          <p:cNvPr id="356" name="Google Shape;356;g3545e54fe64_0_91:notes"/>
           <p:cNvSpPr/>
           <p:nvPr>
             <p:ph idx="2" type="sldImg"/>
@@ -4759,7 +4759,7 @@
       </p:sp>
       <p:sp>
         <p:nvSpPr>
-          <p:cNvPr id="356" name="Google Shape;356;g3545e54fe64_0_91:notes"/>
+          <p:cNvPr id="357" name="Google Shape;357;g3545e54fe64_0_91:notes"/>
           <p:cNvSpPr txBox="1"/>
           <p:nvPr>
             <p:ph idx="1" type="body"/>
@@ -4809,7 +4809,7 @@
   <p:cSld>
     <p:spTree>
       <p:nvGrpSpPr>
-        <p:cNvPr id="361" name="Shape 361"/>
+        <p:cNvPr id="362" name="Shape 362"/>
         <p:cNvGrpSpPr/>
         <p:nvPr/>
       </p:nvGrpSpPr>
@@ -4823,7 +4823,7 @@
       </p:grpSpPr>
       <p:sp>
         <p:nvSpPr>
-          <p:cNvPr id="362" name="Google Shape;362;g3545e54fe64_0_106:notes"/>
+          <p:cNvPr id="363" name="Google Shape;363;g3545e54fe64_0_106:notes"/>
           <p:cNvSpPr/>
           <p:nvPr>
             <p:ph idx="2" type="sldImg"/>
@@ -4858,7 +4858,7 @@
       </p:sp>
       <p:sp>
         <p:nvSpPr>
-          <p:cNvPr id="363" name="Google Shape;363;g3545e54fe64_0_106:notes"/>
+          <p:cNvPr id="364" name="Google Shape;364;g3545e54fe64_0_106:notes"/>
           <p:cNvSpPr txBox="1"/>
           <p:nvPr>
             <p:ph idx="1" type="body"/>
@@ -4908,7 +4908,7 @@
   <p:cSld>
     <p:spTree>
       <p:nvGrpSpPr>
-        <p:cNvPr id="368" name="Shape 368"/>
+        <p:cNvPr id="369" name="Shape 369"/>
         <p:cNvGrpSpPr/>
         <p:nvPr/>
       </p:nvGrpSpPr>
@@ -4922,7 +4922,7 @@
       </p:grpSpPr>
       <p:sp>
         <p:nvSpPr>
-          <p:cNvPr id="369" name="Google Shape;369;g2dbbd0258ec_0_107:notes"/>
+          <p:cNvPr id="370" name="Google Shape;370;g2dbbd0258ec_0_107:notes"/>
           <p:cNvSpPr/>
           <p:nvPr>
             <p:ph idx="2" type="sldImg"/>
@@ -4957,7 +4957,7 @@
       </p:sp>
       <p:sp>
         <p:nvSpPr>
-          <p:cNvPr id="370" name="Google Shape;370;g2dbbd0258ec_0_107:notes"/>
+          <p:cNvPr id="371" name="Google Shape;371;g2dbbd0258ec_0_107:notes"/>
           <p:cNvSpPr txBox="1"/>
           <p:nvPr>
             <p:ph idx="1" type="body"/>
@@ -5007,7 +5007,7 @@
   <p:cSld>
     <p:spTree>
       <p:nvGrpSpPr>
-        <p:cNvPr id="375" name="Shape 375"/>
+        <p:cNvPr id="376" name="Shape 376"/>
         <p:cNvGrpSpPr/>
         <p:nvPr/>
       </p:nvGrpSpPr>
@@ -5021,7 +5021,7 @@
       </p:grpSpPr>
       <p:sp>
         <p:nvSpPr>
-          <p:cNvPr id="376" name="Google Shape;376;g3545e54fe64_0_86:notes"/>
+          <p:cNvPr id="377" name="Google Shape;377;g3545e54fe64_0_86:notes"/>
           <p:cNvSpPr/>
           <p:nvPr>
             <p:ph idx="2" type="sldImg"/>
@@ -5056,7 +5056,7 @@
       </p:sp>
       <p:sp>
         <p:nvSpPr>
-          <p:cNvPr id="377" name="Google Shape;377;g3545e54fe64_0_86:notes"/>
+          <p:cNvPr id="378" name="Google Shape;378;g3545e54fe64_0_86:notes"/>
           <p:cNvSpPr txBox="1"/>
           <p:nvPr>
             <p:ph idx="1" type="body"/>
@@ -5205,7 +5205,7 @@
   <p:cSld>
     <p:spTree>
       <p:nvGrpSpPr>
-        <p:cNvPr id="382" name="Shape 382"/>
+        <p:cNvPr id="383" name="Shape 383"/>
         <p:cNvGrpSpPr/>
         <p:nvPr/>
       </p:nvGrpSpPr>
@@ -5219,7 +5219,7 @@
       </p:grpSpPr>
       <p:sp>
         <p:nvSpPr>
-          <p:cNvPr id="383" name="Google Shape;383;g3574f649a3e_0_248:notes"/>
+          <p:cNvPr id="384" name="Google Shape;384;g3574f649a3e_0_248:notes"/>
           <p:cNvSpPr/>
           <p:nvPr>
             <p:ph idx="2" type="sldImg"/>
@@ -5254,7 +5254,7 @@
       </p:sp>
       <p:sp>
         <p:nvSpPr>
-          <p:cNvPr id="384" name="Google Shape;384;g3574f649a3e_0_248:notes"/>
+          <p:cNvPr id="385" name="Google Shape;385;g3574f649a3e_0_248:notes"/>
           <p:cNvSpPr txBox="1"/>
           <p:nvPr>
             <p:ph idx="1" type="body"/>
@@ -5304,7 +5304,7 @@
   <p:cSld>
     <p:spTree>
       <p:nvGrpSpPr>
-        <p:cNvPr id="389" name="Shape 389"/>
+        <p:cNvPr id="390" name="Shape 390"/>
         <p:cNvGrpSpPr/>
         <p:nvPr/>
       </p:nvGrpSpPr>
@@ -5318,7 +5318,7 @@
       </p:grpSpPr>
       <p:sp>
         <p:nvSpPr>
-          <p:cNvPr id="390" name="Google Shape;390;g3574f649a3e_1_12:notes"/>
+          <p:cNvPr id="391" name="Google Shape;391;g3574f649a3e_1_12:notes"/>
           <p:cNvSpPr/>
           <p:nvPr>
             <p:ph idx="2" type="sldImg"/>
@@ -5353,7 +5353,7 @@
       </p:sp>
       <p:sp>
         <p:nvSpPr>
-          <p:cNvPr id="391" name="Google Shape;391;g3574f649a3e_1_12:notes"/>
+          <p:cNvPr id="392" name="Google Shape;392;g3574f649a3e_1_12:notes"/>
           <p:cNvSpPr txBox="1"/>
           <p:nvPr>
             <p:ph idx="1" type="body"/>
@@ -5403,7 +5403,7 @@
   <p:cSld>
     <p:spTree>
       <p:nvGrpSpPr>
-        <p:cNvPr id="396" name="Shape 396"/>
+        <p:cNvPr id="397" name="Shape 397"/>
         <p:cNvGrpSpPr/>
         <p:nvPr/>
       </p:nvGrpSpPr>
@@ -5417,7 +5417,7 @@
       </p:grpSpPr>
       <p:sp>
         <p:nvSpPr>
-          <p:cNvPr id="397" name="Google Shape;397;g3574f649a3e_0_89:notes"/>
+          <p:cNvPr id="398" name="Google Shape;398;g3574f649a3e_0_89:notes"/>
           <p:cNvSpPr/>
           <p:nvPr>
             <p:ph idx="2" type="sldImg"/>
@@ -5452,7 +5452,7 @@
       </p:sp>
       <p:sp>
         <p:nvSpPr>
-          <p:cNvPr id="398" name="Google Shape;398;g3574f649a3e_0_89:notes"/>
+          <p:cNvPr id="399" name="Google Shape;399;g3574f649a3e_0_89:notes"/>
           <p:cNvSpPr txBox="1"/>
           <p:nvPr>
             <p:ph idx="1" type="body"/>
@@ -5502,7 +5502,7 @@
   <p:cSld>
     <p:spTree>
       <p:nvGrpSpPr>
-        <p:cNvPr id="402" name="Shape 402"/>
+        <p:cNvPr id="403" name="Shape 403"/>
         <p:cNvGrpSpPr/>
         <p:nvPr/>
       </p:nvGrpSpPr>
@@ -5516,7 +5516,7 @@
       </p:grpSpPr>
       <p:sp>
         <p:nvSpPr>
-          <p:cNvPr id="403" name="Google Shape;403;g3574f649a3e_0_94:notes"/>
+          <p:cNvPr id="404" name="Google Shape;404;g3574f649a3e_0_94:notes"/>
           <p:cNvSpPr/>
           <p:nvPr>
             <p:ph idx="2" type="sldImg"/>
@@ -5551,7 +5551,7 @@
       </p:sp>
       <p:sp>
         <p:nvSpPr>
-          <p:cNvPr id="404" name="Google Shape;404;g3574f649a3e_0_94:notes"/>
+          <p:cNvPr id="405" name="Google Shape;405;g3574f649a3e_0_94:notes"/>
           <p:cNvSpPr txBox="1"/>
           <p:nvPr>
             <p:ph idx="1" type="body"/>
@@ -5601,7 +5601,7 @@
   <p:cSld>
     <p:spTree>
       <p:nvGrpSpPr>
-        <p:cNvPr id="409" name="Shape 409"/>
+        <p:cNvPr id="410" name="Shape 410"/>
         <p:cNvGrpSpPr/>
         <p:nvPr/>
       </p:nvGrpSpPr>
@@ -5615,7 +5615,7 @@
       </p:grpSpPr>
       <p:sp>
         <p:nvSpPr>
-          <p:cNvPr id="410" name="Google Shape;410;g3574f649a3e_0_100:notes"/>
+          <p:cNvPr id="411" name="Google Shape;411;g3574f649a3e_0_100:notes"/>
           <p:cNvSpPr/>
           <p:nvPr>
             <p:ph idx="2" type="sldImg"/>
@@ -5650,7 +5650,7 @@
       </p:sp>
       <p:sp>
         <p:nvSpPr>
-          <p:cNvPr id="411" name="Google Shape;411;g3574f649a3e_0_100:notes"/>
+          <p:cNvPr id="412" name="Google Shape;412;g3574f649a3e_0_100:notes"/>
           <p:cNvSpPr txBox="1"/>
           <p:nvPr>
             <p:ph idx="1" type="body"/>
@@ -5700,7 +5700,7 @@
   <p:cSld>
     <p:spTree>
       <p:nvGrpSpPr>
-        <p:cNvPr id="416" name="Shape 416"/>
+        <p:cNvPr id="417" name="Shape 417"/>
         <p:cNvGrpSpPr/>
         <p:nvPr/>
       </p:nvGrpSpPr>
@@ -5714,7 +5714,7 @@
       </p:grpSpPr>
       <p:sp>
         <p:nvSpPr>
-          <p:cNvPr id="417" name="Google Shape;417;g3574f649a3e_0_106:notes"/>
+          <p:cNvPr id="418" name="Google Shape;418;g3574f649a3e_0_106:notes"/>
           <p:cNvSpPr/>
           <p:nvPr>
             <p:ph idx="2" type="sldImg"/>
@@ -5749,7 +5749,7 @@
       </p:sp>
       <p:sp>
         <p:nvSpPr>
-          <p:cNvPr id="418" name="Google Shape;418;g3574f649a3e_0_106:notes"/>
+          <p:cNvPr id="419" name="Google Shape;419;g3574f649a3e_0_106:notes"/>
           <p:cNvSpPr txBox="1"/>
           <p:nvPr>
             <p:ph idx="1" type="body"/>
@@ -5799,7 +5799,7 @@
   <p:cSld>
     <p:spTree>
       <p:nvGrpSpPr>
-        <p:cNvPr id="423" name="Shape 423"/>
+        <p:cNvPr id="424" name="Shape 424"/>
         <p:cNvGrpSpPr/>
         <p:nvPr/>
       </p:nvGrpSpPr>
@@ -5813,7 +5813,7 @@
       </p:grpSpPr>
       <p:sp>
         <p:nvSpPr>
-          <p:cNvPr id="424" name="Google Shape;424;g3574f649a3e_0_66:notes"/>
+          <p:cNvPr id="425" name="Google Shape;425;g3574f649a3e_0_66:notes"/>
           <p:cNvSpPr/>
           <p:nvPr>
             <p:ph idx="2" type="sldImg"/>
@@ -5848,7 +5848,7 @@
       </p:sp>
       <p:sp>
         <p:nvSpPr>
-          <p:cNvPr id="425" name="Google Shape;425;g3574f649a3e_0_66:notes"/>
+          <p:cNvPr id="426" name="Google Shape;426;g3574f649a3e_0_66:notes"/>
           <p:cNvSpPr txBox="1"/>
           <p:nvPr>
             <p:ph idx="1" type="body"/>
@@ -5898,7 +5898,7 @@
   <p:cSld>
     <p:spTree>
       <p:nvGrpSpPr>
-        <p:cNvPr id="429" name="Shape 429"/>
+        <p:cNvPr id="430" name="Shape 430"/>
         <p:cNvGrpSpPr/>
         <p:nvPr/>
       </p:nvGrpSpPr>
@@ -5912,7 +5912,7 @@
       </p:grpSpPr>
       <p:sp>
         <p:nvSpPr>
-          <p:cNvPr id="430" name="Google Shape;430;g3574f649a3e_0_71:notes"/>
+          <p:cNvPr id="431" name="Google Shape;431;g3574f649a3e_0_71:notes"/>
           <p:cNvSpPr/>
           <p:nvPr>
             <p:ph idx="2" type="sldImg"/>
@@ -5947,7 +5947,7 @@
       </p:sp>
       <p:sp>
         <p:nvSpPr>
-          <p:cNvPr id="431" name="Google Shape;431;g3574f649a3e_0_71:notes"/>
+          <p:cNvPr id="432" name="Google Shape;432;g3574f649a3e_0_71:notes"/>
           <p:cNvSpPr txBox="1"/>
           <p:nvPr>
             <p:ph idx="1" type="body"/>
@@ -5997,7 +5997,7 @@
   <p:cSld>
     <p:spTree>
       <p:nvGrpSpPr>
-        <p:cNvPr id="437" name="Shape 437"/>
+        <p:cNvPr id="438" name="Shape 438"/>
         <p:cNvGrpSpPr/>
         <p:nvPr/>
       </p:nvGrpSpPr>
@@ -6011,7 +6011,7 @@
       </p:grpSpPr>
       <p:sp>
         <p:nvSpPr>
-          <p:cNvPr id="438" name="Google Shape;438;g3574f649a3e_0_236:notes"/>
+          <p:cNvPr id="439" name="Google Shape;439;g3574f649a3e_0_236:notes"/>
           <p:cNvSpPr/>
           <p:nvPr>
             <p:ph idx="2" type="sldImg"/>
@@ -6046,7 +6046,7 @@
       </p:sp>
       <p:sp>
         <p:nvSpPr>
-          <p:cNvPr id="439" name="Google Shape;439;g3574f649a3e_0_236:notes"/>
+          <p:cNvPr id="440" name="Google Shape;440;g3574f649a3e_0_236:notes"/>
           <p:cNvSpPr txBox="1"/>
           <p:nvPr>
             <p:ph idx="1" type="body"/>
@@ -6096,7 +6096,7 @@
   <p:cSld>
     <p:spTree>
       <p:nvGrpSpPr>
-        <p:cNvPr id="444" name="Shape 444"/>
+        <p:cNvPr id="445" name="Shape 445"/>
         <p:cNvGrpSpPr/>
         <p:nvPr/>
       </p:nvGrpSpPr>
@@ -6110,7 +6110,7 @@
       </p:grpSpPr>
       <p:sp>
         <p:nvSpPr>
-          <p:cNvPr id="445" name="Google Shape;445;g3574f649a3e_0_219:notes"/>
+          <p:cNvPr id="446" name="Google Shape;446;g3574f649a3e_0_219:notes"/>
           <p:cNvSpPr/>
           <p:nvPr>
             <p:ph idx="2" type="sldImg"/>
@@ -6145,7 +6145,7 @@
       </p:sp>
       <p:sp>
         <p:nvSpPr>
-          <p:cNvPr id="446" name="Google Shape;446;g3574f649a3e_0_219:notes"/>
+          <p:cNvPr id="447" name="Google Shape;447;g3574f649a3e_0_219:notes"/>
           <p:cNvSpPr txBox="1"/>
           <p:nvPr>
             <p:ph idx="1" type="body"/>
@@ -6294,7 +6294,7 @@
   <p:cSld>
     <p:spTree>
       <p:nvGrpSpPr>
-        <p:cNvPr id="450" name="Shape 450"/>
+        <p:cNvPr id="451" name="Shape 451"/>
         <p:cNvGrpSpPr/>
         <p:nvPr/>
       </p:nvGrpSpPr>
@@ -6308,7 +6308,7 @@
       </p:grpSpPr>
       <p:sp>
         <p:nvSpPr>
-          <p:cNvPr id="451" name="Google Shape;451;g3574f649a3e_0_224:notes"/>
+          <p:cNvPr id="452" name="Google Shape;452;g3574f649a3e_0_224:notes"/>
           <p:cNvSpPr/>
           <p:nvPr>
             <p:ph idx="2" type="sldImg"/>
@@ -6343,7 +6343,7 @@
       </p:sp>
       <p:sp>
         <p:nvSpPr>
-          <p:cNvPr id="452" name="Google Shape;452;g3574f649a3e_0_224:notes"/>
+          <p:cNvPr id="453" name="Google Shape;453;g3574f649a3e_0_224:notes"/>
           <p:cNvSpPr txBox="1"/>
           <p:nvPr>
             <p:ph idx="1" type="body"/>
@@ -12724,7 +12724,7 @@
             </a:pPr>
             <a:r>
               <a:rPr lang="en"/>
-              <a:t>Theory building</a:t>
+              <a:t>QDA in theory building</a:t>
             </a:r>
             <a:endParaRPr/>
           </a:p>
@@ -12741,7 +12741,7 @@
             </a:pPr>
             <a:r>
               <a:rPr lang="en"/>
-              <a:t>QDA methods</a:t>
+              <a:t>QDA artifacts</a:t>
             </a:r>
             <a:endParaRPr/>
           </a:p>
@@ -12758,7 +12758,7 @@
             </a:pPr>
             <a:r>
               <a:rPr lang="en"/>
-              <a:t>QDA artifacts</a:t>
+              <a:t>QDA methods</a:t>
             </a:r>
             <a:endParaRPr/>
           </a:p>
@@ -13459,7 +13459,7 @@
             </a:pPr>
             <a:r>
               <a:rPr lang="en"/>
-              <a:t>Card Sorting</a:t>
+              <a:t>Card Sorting [1]</a:t>
             </a:r>
             <a:endParaRPr/>
           </a:p>
@@ -13516,7 +13516,7 @@
             </a:pPr>
             <a:r>
               <a:rPr lang="en"/>
-              <a:t>Name item [1] and write on card</a:t>
+              <a:t>Name item [2] and write on card</a:t>
             </a:r>
             <a:endParaRPr/>
           </a:p>
@@ -13685,11 +13685,57 @@
               <a:spcAft>
                 <a:spcPts val="0"/>
               </a:spcAft>
-              <a:buNone/>
-            </a:pPr>
-            <a:r>
-              <a:rPr lang="en"/>
-              <a:t>[1] Item, topic, theme, artifact, … depends on context and is relative to research question</a:t>
+              <a:buClr>
+                <a:schemeClr val="dk1"/>
+              </a:buClr>
+              <a:buSzPts val="1100"/>
+              <a:buFont typeface="Arial"/>
+              <a:buNone/>
+            </a:pPr>
+            <a:r>
+              <a:rPr lang="en">
+                <a:solidFill>
+                  <a:schemeClr val="dk1"/>
+                </a:solidFill>
+              </a:rPr>
+              <a:t>[1] See </a:t>
+            </a:r>
+            <a:r>
+              <a:rPr lang="en" u="sng">
+                <a:solidFill>
+                  <a:schemeClr val="hlink"/>
+                </a:solidFill>
+                <a:hlinkClick r:id="rId4"/>
+              </a:rPr>
+              <a:t>Hudson (2013)</a:t>
+            </a:r>
+            <a:r>
+              <a:rPr lang="en">
+                <a:solidFill>
+                  <a:schemeClr val="dk1"/>
+                </a:solidFill>
+              </a:rPr>
+              <a:t>: Card sorting.</a:t>
+            </a:r>
+            <a:endParaRPr>
+              <a:solidFill>
+                <a:schemeClr val="dk1"/>
+              </a:solidFill>
+            </a:endParaRPr>
+          </a:p>
+          <a:p>
+            <a:pPr indent="0" lvl="0" marL="0" rtl="0" algn="l">
+              <a:spcBef>
+                <a:spcPts val="0"/>
+              </a:spcBef>
+              <a:spcAft>
+                <a:spcPts val="0"/>
+              </a:spcAft>
+              <a:buNone/>
+            </a:pPr>
+            <a:r>
+              <a:rPr lang="en"/>
+              <a:t>[2] Item, topic, theme, artifact, … depends on context and is relative to research question</a:t>
             </a:r>
             <a:endParaRPr/>
           </a:p>
@@ -14082,7 +14128,7 @@
             </a:pPr>
             <a:r>
               <a:rPr lang="en"/>
-              <a:t>Thematic Analysis</a:t>
+              <a:t>Thematic Analysis [1]</a:t>
             </a:r>
             <a:endParaRPr/>
           </a:p>
@@ -14332,6 +14378,61 @@
               <a:t> </a:t>
             </a:r>
             <a:endParaRPr b="0" sz="1000"/>
+          </a:p>
+        </p:txBody>
+      </p:sp>
+      <p:sp>
+        <p:nvSpPr>
+          <p:cNvPr id="211" name="Google Shape;211;p32"/>
+          <p:cNvSpPr txBox="1"/>
+          <p:nvPr/>
+        </p:nvSpPr>
+        <p:spPr>
+          <a:xfrm>
+            <a:off x="0" y="4233672"/>
+            <a:ext cx="7315200" cy="914400"/>
+          </a:xfrm>
+          <a:prstGeom prst="rect">
+            <a:avLst/>
+          </a:prstGeom>
+          <a:noFill/>
+          <a:ln>
+            <a:noFill/>
+          </a:ln>
+        </p:spPr>
+        <p:txBody>
+          <a:bodyPr anchorCtr="0" anchor="b" bIns="91425" lIns="91425" spcFirstLastPara="1" rIns="91425" wrap="square" tIns="91425">
+            <a:noAutofit/>
+          </a:bodyPr>
+          <a:lstStyle/>
+          <a:p>
+            <a:pPr indent="0" lvl="0" marL="0" rtl="0" algn="l">
+              <a:spcBef>
+                <a:spcPts val="0"/>
+              </a:spcBef>
+              <a:spcAft>
+                <a:spcPts val="0"/>
+              </a:spcAft>
+              <a:buNone/>
+            </a:pPr>
+            <a:r>
+              <a:rPr lang="en"/>
+              <a:t>[1] See </a:t>
+            </a:r>
+            <a:r>
+              <a:rPr lang="en" u="sng">
+                <a:solidFill>
+                  <a:schemeClr val="hlink"/>
+                </a:solidFill>
+                <a:hlinkClick r:id="rId4"/>
+              </a:rPr>
+              <a:t>Braun &amp; Clarke (2012)</a:t>
+            </a:r>
+            <a:r>
+              <a:rPr lang="en"/>
+              <a:t>: Thematic analysis.</a:t>
+            </a:r>
+            <a:endParaRPr/>
           </a:p>
         </p:txBody>
       </p:sp>
@@ -14348,7 +14449,7 @@
   <p:cSld>
     <p:spTree>
       <p:nvGrpSpPr>
-        <p:cNvPr id="214" name="Shape 214"/>
+        <p:cNvPr id="215" name="Shape 215"/>
         <p:cNvGrpSpPr/>
         <p:nvPr/>
       </p:nvGrpSpPr>
@@ -14362,7 +14463,7 @@
       </p:grpSpPr>
       <p:sp>
         <p:nvSpPr>
-          <p:cNvPr id="215" name="Google Shape;215;p33"/>
+          <p:cNvPr id="216" name="Google Shape;216;p33"/>
           <p:cNvSpPr txBox="1"/>
           <p:nvPr>
             <p:ph idx="1" type="body"/>
@@ -14517,7 +14618,7 @@
       </p:sp>
       <p:sp>
         <p:nvSpPr>
-          <p:cNvPr id="216" name="Google Shape;216;p33"/>
+          <p:cNvPr id="217" name="Google Shape;217;p33"/>
           <p:cNvSpPr txBox="1"/>
           <p:nvPr>
             <p:ph type="title"/>
@@ -14549,7 +14650,7 @@
             </a:pPr>
             <a:r>
               <a:rPr lang="en"/>
-              <a:t>Inductive Coding [1]</a:t>
+              <a:t>Inductive Coding [1] [2]</a:t>
             </a:r>
             <a:endParaRPr/>
           </a:p>
@@ -14557,7 +14658,7 @@
       </p:sp>
       <p:sp>
         <p:nvSpPr>
-          <p:cNvPr id="217" name="Google Shape;217;p33"/>
+          <p:cNvPr id="218" name="Google Shape;218;p33"/>
           <p:cNvSpPr txBox="1"/>
           <p:nvPr>
             <p:ph idx="12" type="sldNum"/>
@@ -14622,7 +14723,7 @@
       </p:sp>
       <p:sp>
         <p:nvSpPr>
-          <p:cNvPr id="218" name="Google Shape;218;p33"/>
+          <p:cNvPr id="219" name="Google Shape;219;p33"/>
           <p:cNvSpPr txBox="1"/>
           <p:nvPr/>
         </p:nvSpPr>
@@ -14652,11 +14753,57 @@
               <a:spcAft>
                 <a:spcPts val="0"/>
               </a:spcAft>
-              <a:buNone/>
-            </a:pPr>
-            <a:r>
-              <a:rPr lang="en"/>
-              <a:t>[1] My shorthand for coding according to Corbin &amp; Strauss (2008) [DR]</a:t>
+              <a:buClr>
+                <a:schemeClr val="dk1"/>
+              </a:buClr>
+              <a:buSzPts val="1100"/>
+              <a:buFont typeface="Arial"/>
+              <a:buNone/>
+            </a:pPr>
+            <a:r>
+              <a:rPr lang="en">
+                <a:solidFill>
+                  <a:schemeClr val="dk1"/>
+                </a:solidFill>
+              </a:rPr>
+              <a:t>[1] See </a:t>
+            </a:r>
+            <a:r>
+              <a:rPr lang="en" u="sng">
+                <a:solidFill>
+                  <a:schemeClr val="hlink"/>
+                </a:solidFill>
+                <a:hlinkClick r:id="rId4"/>
+              </a:rPr>
+              <a:t>Corbin &amp; Strauss (2008)</a:t>
+            </a:r>
+            <a:r>
+              <a:rPr lang="en">
+                <a:solidFill>
+                  <a:schemeClr val="dk1"/>
+                </a:solidFill>
+              </a:rPr>
+              <a:t>: Qualitative research, 3rd edition.</a:t>
+            </a:r>
+            <a:endParaRPr>
+              <a:solidFill>
+                <a:schemeClr val="dk1"/>
+              </a:solidFill>
+            </a:endParaRPr>
+          </a:p>
+          <a:p>
+            <a:pPr indent="0" lvl="0" marL="0" rtl="0" algn="l">
+              <a:spcBef>
+                <a:spcPts val="0"/>
+              </a:spcBef>
+              <a:spcAft>
+                <a:spcPts val="0"/>
+              </a:spcAft>
+              <a:buNone/>
+            </a:pPr>
+            <a:r>
+              <a:rPr lang="en"/>
+              <a:t>[2] My shorthand for coding according to Corbin &amp; Strauss (2008) [DR]</a:t>
             </a:r>
             <a:endParaRPr/>
           </a:p>
@@ -14675,7 +14822,7 @@
   <p:cSld>
     <p:spTree>
       <p:nvGrpSpPr>
-        <p:cNvPr id="222" name="Shape 222"/>
+        <p:cNvPr id="223" name="Shape 223"/>
         <p:cNvGrpSpPr/>
         <p:nvPr/>
       </p:nvGrpSpPr>
@@ -14689,7 +14836,7 @@
       </p:grpSpPr>
       <p:sp>
         <p:nvSpPr>
-          <p:cNvPr id="223" name="Google Shape;223;p34"/>
+          <p:cNvPr id="224" name="Google Shape;224;p34"/>
           <p:cNvSpPr txBox="1"/>
           <p:nvPr>
             <p:ph type="title"/>
@@ -14729,7 +14876,7 @@
       </p:sp>
       <p:sp>
         <p:nvSpPr>
-          <p:cNvPr id="224" name="Google Shape;224;p34"/>
+          <p:cNvPr id="225" name="Google Shape;225;p34"/>
           <p:cNvSpPr txBox="1"/>
           <p:nvPr>
             <p:ph idx="1" type="body"/>
@@ -14808,7 +14955,7 @@
       </p:sp>
       <p:sp>
         <p:nvSpPr>
-          <p:cNvPr id="225" name="Google Shape;225;p34"/>
+          <p:cNvPr id="226" name="Google Shape;226;p34"/>
           <p:cNvSpPr txBox="1"/>
           <p:nvPr>
             <p:ph idx="12" type="sldNum"/>
@@ -14873,7 +15020,7 @@
       </p:sp>
       <p:sp>
         <p:nvSpPr>
-          <p:cNvPr id="226" name="Google Shape;226;p34"/>
+          <p:cNvPr id="227" name="Google Shape;227;p34"/>
           <p:cNvSpPr txBox="1"/>
           <p:nvPr/>
         </p:nvSpPr>
@@ -14928,7 +15075,7 @@
       </p:sp>
       <p:pic>
         <p:nvPicPr>
-          <p:cNvPr id="227" name="Google Shape;227;p34"/>
+          <p:cNvPr id="228" name="Google Shape;228;p34"/>
           <p:cNvPicPr preferRelativeResize="0"/>
           <p:nvPr/>
         </p:nvPicPr>
@@ -14967,7 +15114,7 @@
   <p:cSld>
     <p:spTree>
       <p:nvGrpSpPr>
-        <p:cNvPr id="231" name="Shape 231"/>
+        <p:cNvPr id="232" name="Shape 232"/>
         <p:cNvGrpSpPr/>
         <p:nvPr/>
       </p:nvGrpSpPr>
@@ -14981,7 +15128,7 @@
       </p:grpSpPr>
       <p:sp>
         <p:nvSpPr>
-          <p:cNvPr id="232" name="Google Shape;232;p35"/>
+          <p:cNvPr id="233" name="Google Shape;233;p35"/>
           <p:cNvSpPr txBox="1"/>
           <p:nvPr>
             <p:ph type="title"/>
@@ -15021,7 +15168,7 @@
       </p:sp>
       <p:sp>
         <p:nvSpPr>
-          <p:cNvPr id="233" name="Google Shape;233;p35"/>
+          <p:cNvPr id="234" name="Google Shape;234;p35"/>
           <p:cNvSpPr txBox="1"/>
           <p:nvPr>
             <p:ph idx="12" type="sldNum"/>
@@ -15086,7 +15233,7 @@
       </p:sp>
       <p:graphicFrame>
         <p:nvGraphicFramePr>
-          <p:cNvPr id="234" name="Google Shape;234;p35"/>
+          <p:cNvPr id="235" name="Google Shape;235;p35"/>
           <p:cNvGraphicFramePr/>
           <p:nvPr/>
         </p:nvGraphicFramePr>
@@ -15099,7 +15246,7 @@
             <a:tbl>
               <a:tblPr>
                 <a:noFill/>
-                <a:tableStyleId>{5CB1D727-860D-47C4-96D7-29960D34008E}</a:tableStyleId>
+                <a:tableStyleId>{BCD062AF-5B59-40DB-9C61-5F2C5996C835}</a:tableStyleId>
               </a:tblPr>
               <a:tblGrid>
                 <a:gridCol w="1719075"/>
@@ -16197,7 +16344,7 @@
                             <a:schemeClr val="lt1"/>
                           </a:solidFill>
                         </a:rPr>
-                        <a:t>Analysis</a:t>
+                        <a:t>Extraction</a:t>
                       </a:r>
                       <a:endParaRPr b="1">
                         <a:solidFill>
@@ -16741,7 +16888,7 @@
   <p:cSld>
     <p:spTree>
       <p:nvGrpSpPr>
-        <p:cNvPr id="238" name="Shape 238"/>
+        <p:cNvPr id="239" name="Shape 239"/>
         <p:cNvGrpSpPr/>
         <p:nvPr/>
       </p:nvGrpSpPr>
@@ -16755,7 +16902,7 @@
       </p:grpSpPr>
       <p:sp>
         <p:nvSpPr>
-          <p:cNvPr id="239" name="Google Shape;239;p36"/>
+          <p:cNvPr id="240" name="Google Shape;240;p36"/>
           <p:cNvSpPr txBox="1"/>
           <p:nvPr>
             <p:ph type="title"/>
@@ -16795,7 +16942,7 @@
       </p:sp>
       <p:sp>
         <p:nvSpPr>
-          <p:cNvPr id="240" name="Google Shape;240;p36"/>
+          <p:cNvPr id="241" name="Google Shape;241;p36"/>
           <p:cNvSpPr txBox="1"/>
           <p:nvPr>
             <p:ph idx="12" type="sldNum"/>
@@ -16860,7 +17007,7 @@
       </p:sp>
       <p:pic>
         <p:nvPicPr>
-          <p:cNvPr id="241" name="Google Shape;241;p36"/>
+          <p:cNvPr id="242" name="Google Shape;242;p36"/>
           <p:cNvPicPr preferRelativeResize="0"/>
           <p:nvPr/>
         </p:nvPicPr>
@@ -16945,7 +17092,7 @@
             </a:pPr>
             <a:r>
               <a:rPr lang="en"/>
-              <a:t>1. Theory Building</a:t>
+              <a:t>1. QDA in Theory Building</a:t>
             </a:r>
             <a:endParaRPr/>
           </a:p>
@@ -17029,7 +17176,7 @@
   <p:cSld>
     <p:spTree>
       <p:nvGrpSpPr>
-        <p:cNvPr id="245" name="Shape 245"/>
+        <p:cNvPr id="246" name="Shape 246"/>
         <p:cNvGrpSpPr/>
         <p:nvPr/>
       </p:nvGrpSpPr>
@@ -17043,7 +17190,7 @@
       </p:grpSpPr>
       <p:sp>
         <p:nvSpPr>
-          <p:cNvPr id="246" name="Google Shape;246;p37"/>
+          <p:cNvPr id="247" name="Google Shape;247;p37"/>
           <p:cNvSpPr txBox="1"/>
           <p:nvPr>
             <p:ph type="title"/>
@@ -17083,7 +17230,7 @@
       </p:sp>
       <p:sp>
         <p:nvSpPr>
-          <p:cNvPr id="247" name="Google Shape;247;p37"/>
+          <p:cNvPr id="248" name="Google Shape;248;p37"/>
           <p:cNvSpPr txBox="1"/>
           <p:nvPr>
             <p:ph idx="1" type="body"/>
@@ -17164,7 +17311,7 @@
       </p:sp>
       <p:sp>
         <p:nvSpPr>
-          <p:cNvPr id="248" name="Google Shape;248;p37"/>
+          <p:cNvPr id="249" name="Google Shape;249;p37"/>
           <p:cNvSpPr txBox="1"/>
           <p:nvPr>
             <p:ph idx="12" type="sldNum"/>
@@ -17240,7 +17387,7 @@
   <p:cSld>
     <p:spTree>
       <p:nvGrpSpPr>
-        <p:cNvPr id="252" name="Shape 252"/>
+        <p:cNvPr id="253" name="Shape 253"/>
         <p:cNvGrpSpPr/>
         <p:nvPr/>
       </p:nvGrpSpPr>
@@ -17254,7 +17401,7 @@
       </p:grpSpPr>
       <p:sp>
         <p:nvSpPr>
-          <p:cNvPr id="253" name="Google Shape;253;p38"/>
+          <p:cNvPr id="254" name="Google Shape;254;p38"/>
           <p:cNvSpPr txBox="1"/>
           <p:nvPr>
             <p:ph type="title"/>
@@ -17294,7 +17441,7 @@
       </p:sp>
       <p:sp>
         <p:nvSpPr>
-          <p:cNvPr id="254" name="Google Shape;254;p38"/>
+          <p:cNvPr id="255" name="Google Shape;255;p38"/>
           <p:cNvSpPr txBox="1"/>
           <p:nvPr>
             <p:ph idx="12" type="sldNum"/>
@@ -17370,7 +17517,7 @@
   <p:cSld>
     <p:spTree>
       <p:nvGrpSpPr>
-        <p:cNvPr id="258" name="Shape 258"/>
+        <p:cNvPr id="259" name="Shape 259"/>
         <p:cNvGrpSpPr/>
         <p:nvPr/>
       </p:nvGrpSpPr>
@@ -17384,7 +17531,7 @@
       </p:grpSpPr>
       <p:sp>
         <p:nvSpPr>
-          <p:cNvPr id="259" name="Google Shape;259;p39"/>
+          <p:cNvPr id="260" name="Google Shape;260;p39"/>
           <p:cNvSpPr txBox="1"/>
           <p:nvPr>
             <p:ph type="title"/>
@@ -17424,7 +17571,7 @@
       </p:sp>
       <p:sp>
         <p:nvSpPr>
-          <p:cNvPr id="260" name="Google Shape;260;p39"/>
+          <p:cNvPr id="261" name="Google Shape;261;p39"/>
           <p:cNvSpPr txBox="1"/>
           <p:nvPr>
             <p:ph idx="1" type="body"/>
@@ -17660,7 +17807,7 @@
       </p:sp>
       <p:sp>
         <p:nvSpPr>
-          <p:cNvPr id="261" name="Google Shape;261;p39"/>
+          <p:cNvPr id="262" name="Google Shape;262;p39"/>
           <p:cNvSpPr txBox="1"/>
           <p:nvPr>
             <p:ph idx="12" type="sldNum"/>
@@ -17736,7 +17883,7 @@
   <p:cSld>
     <p:spTree>
       <p:nvGrpSpPr>
-        <p:cNvPr id="265" name="Shape 265"/>
+        <p:cNvPr id="266" name="Shape 266"/>
         <p:cNvGrpSpPr/>
         <p:nvPr/>
       </p:nvGrpSpPr>
@@ -17750,7 +17897,7 @@
       </p:grpSpPr>
       <p:sp>
         <p:nvSpPr>
-          <p:cNvPr id="266" name="Google Shape;266;p40"/>
+          <p:cNvPr id="267" name="Google Shape;267;p40"/>
           <p:cNvSpPr txBox="1"/>
           <p:nvPr>
             <p:ph type="title"/>
@@ -17790,7 +17937,7 @@
       </p:sp>
       <p:sp>
         <p:nvSpPr>
-          <p:cNvPr id="267" name="Google Shape;267;p40"/>
+          <p:cNvPr id="268" name="Google Shape;268;p40"/>
           <p:cNvSpPr txBox="1"/>
           <p:nvPr>
             <p:ph idx="1" type="body"/>
@@ -17910,7 +18057,7 @@
       </p:sp>
       <p:sp>
         <p:nvSpPr>
-          <p:cNvPr id="268" name="Google Shape;268;p40"/>
+          <p:cNvPr id="269" name="Google Shape;269;p40"/>
           <p:cNvSpPr txBox="1"/>
           <p:nvPr>
             <p:ph idx="12" type="sldNum"/>
@@ -17986,7 +18133,7 @@
   <p:cSld>
     <p:spTree>
       <p:nvGrpSpPr>
-        <p:cNvPr id="272" name="Shape 272"/>
+        <p:cNvPr id="273" name="Shape 273"/>
         <p:cNvGrpSpPr/>
         <p:nvPr/>
       </p:nvGrpSpPr>
@@ -18000,7 +18147,7 @@
       </p:grpSpPr>
       <p:sp>
         <p:nvSpPr>
-          <p:cNvPr id="273" name="Google Shape;273;p41"/>
+          <p:cNvPr id="274" name="Google Shape;274;p41"/>
           <p:cNvSpPr txBox="1"/>
           <p:nvPr>
             <p:ph type="title"/>
@@ -18040,7 +18187,7 @@
       </p:sp>
       <p:sp>
         <p:nvSpPr>
-          <p:cNvPr id="274" name="Google Shape;274;p41"/>
+          <p:cNvPr id="275" name="Google Shape;275;p41"/>
           <p:cNvSpPr txBox="1"/>
           <p:nvPr>
             <p:ph idx="1" type="body"/>
@@ -18147,7 +18294,7 @@
       </p:sp>
       <p:sp>
         <p:nvSpPr>
-          <p:cNvPr id="275" name="Google Shape;275;p41"/>
+          <p:cNvPr id="276" name="Google Shape;276;p41"/>
           <p:cNvSpPr txBox="1"/>
           <p:nvPr>
             <p:ph idx="12" type="sldNum"/>
@@ -18223,7 +18370,7 @@
   <p:cSld>
     <p:spTree>
       <p:nvGrpSpPr>
-        <p:cNvPr id="279" name="Shape 279"/>
+        <p:cNvPr id="280" name="Shape 280"/>
         <p:cNvGrpSpPr/>
         <p:nvPr/>
       </p:nvGrpSpPr>
@@ -18237,7 +18384,7 @@
       </p:grpSpPr>
       <p:sp>
         <p:nvSpPr>
-          <p:cNvPr id="280" name="Google Shape;280;p42"/>
+          <p:cNvPr id="281" name="Google Shape;281;p42"/>
           <p:cNvSpPr txBox="1"/>
           <p:nvPr>
             <p:ph type="title"/>
@@ -18277,7 +18424,7 @@
       </p:sp>
       <p:sp>
         <p:nvSpPr>
-          <p:cNvPr id="281" name="Google Shape;281;p42"/>
+          <p:cNvPr id="282" name="Google Shape;282;p42"/>
           <p:cNvSpPr txBox="1"/>
           <p:nvPr>
             <p:ph idx="12" type="sldNum"/>
@@ -18342,7 +18489,7 @@
       </p:sp>
       <p:sp>
         <p:nvSpPr>
-          <p:cNvPr id="282" name="Google Shape;282;p42"/>
+          <p:cNvPr id="283" name="Google Shape;283;p42"/>
           <p:cNvSpPr txBox="1"/>
           <p:nvPr>
             <p:ph idx="1" type="body"/>
@@ -18489,7 +18636,7 @@
   <p:cSld>
     <p:spTree>
       <p:nvGrpSpPr>
-        <p:cNvPr id="286" name="Shape 286"/>
+        <p:cNvPr id="287" name="Shape 287"/>
         <p:cNvGrpSpPr/>
         <p:nvPr/>
       </p:nvGrpSpPr>
@@ -18503,7 +18650,7 @@
       </p:grpSpPr>
       <p:sp>
         <p:nvSpPr>
-          <p:cNvPr id="287" name="Google Shape;287;p43"/>
+          <p:cNvPr id="288" name="Google Shape;288;p43"/>
           <p:cNvSpPr txBox="1"/>
           <p:nvPr>
             <p:ph type="title"/>
@@ -18543,7 +18690,7 @@
       </p:sp>
       <p:sp>
         <p:nvSpPr>
-          <p:cNvPr id="288" name="Google Shape;288;p43"/>
+          <p:cNvPr id="289" name="Google Shape;289;p43"/>
           <p:cNvSpPr txBox="1"/>
           <p:nvPr>
             <p:ph idx="1" type="body"/>
@@ -18682,7 +18829,7 @@
       </p:sp>
       <p:sp>
         <p:nvSpPr>
-          <p:cNvPr id="289" name="Google Shape;289;p43"/>
+          <p:cNvPr id="290" name="Google Shape;290;p43"/>
           <p:cNvSpPr txBox="1"/>
           <p:nvPr>
             <p:ph idx="12" type="sldNum"/>
@@ -18758,7 +18905,7 @@
   <p:cSld>
     <p:spTree>
       <p:nvGrpSpPr>
-        <p:cNvPr id="293" name="Shape 293"/>
+        <p:cNvPr id="294" name="Shape 294"/>
         <p:cNvGrpSpPr/>
         <p:nvPr/>
       </p:nvGrpSpPr>
@@ -18772,7 +18919,7 @@
       </p:grpSpPr>
       <p:sp>
         <p:nvSpPr>
-          <p:cNvPr id="294" name="Google Shape;294;p44"/>
+          <p:cNvPr id="295" name="Google Shape;295;p44"/>
           <p:cNvSpPr txBox="1"/>
           <p:nvPr>
             <p:ph type="title"/>
@@ -18812,7 +18959,7 @@
       </p:sp>
       <p:sp>
         <p:nvSpPr>
-          <p:cNvPr id="295" name="Google Shape;295;p44"/>
+          <p:cNvPr id="296" name="Google Shape;296;p44"/>
           <p:cNvSpPr txBox="1"/>
           <p:nvPr>
             <p:ph idx="1" type="body"/>
@@ -18917,7 +19064,7 @@
       </p:sp>
       <p:sp>
         <p:nvSpPr>
-          <p:cNvPr id="296" name="Google Shape;296;p44"/>
+          <p:cNvPr id="297" name="Google Shape;297;p44"/>
           <p:cNvSpPr txBox="1"/>
           <p:nvPr>
             <p:ph idx="12" type="sldNum"/>
@@ -18993,7 +19140,7 @@
   <p:cSld>
     <p:spTree>
       <p:nvGrpSpPr>
-        <p:cNvPr id="300" name="Shape 300"/>
+        <p:cNvPr id="301" name="Shape 301"/>
         <p:cNvGrpSpPr/>
         <p:nvPr/>
       </p:nvGrpSpPr>
@@ -19007,7 +19154,7 @@
       </p:grpSpPr>
       <p:sp>
         <p:nvSpPr>
-          <p:cNvPr id="301" name="Google Shape;301;p45"/>
+          <p:cNvPr id="302" name="Google Shape;302;p45"/>
           <p:cNvSpPr txBox="1"/>
           <p:nvPr>
             <p:ph type="title"/>
@@ -19047,7 +19194,7 @@
       </p:sp>
       <p:sp>
         <p:nvSpPr>
-          <p:cNvPr id="302" name="Google Shape;302;p45"/>
+          <p:cNvPr id="303" name="Google Shape;303;p45"/>
           <p:cNvSpPr txBox="1"/>
           <p:nvPr>
             <p:ph idx="1" type="body"/>
@@ -19119,7 +19266,7 @@
       </p:sp>
       <p:sp>
         <p:nvSpPr>
-          <p:cNvPr id="303" name="Google Shape;303;p45"/>
+          <p:cNvPr id="304" name="Google Shape;304;p45"/>
           <p:cNvSpPr txBox="1"/>
           <p:nvPr>
             <p:ph idx="12" type="sldNum"/>
@@ -19195,7 +19342,7 @@
   <p:cSld>
     <p:spTree>
       <p:nvGrpSpPr>
-        <p:cNvPr id="307" name="Shape 307"/>
+        <p:cNvPr id="308" name="Shape 308"/>
         <p:cNvGrpSpPr/>
         <p:nvPr/>
       </p:nvGrpSpPr>
@@ -19209,7 +19356,7 @@
       </p:grpSpPr>
       <p:sp>
         <p:nvSpPr>
-          <p:cNvPr id="308" name="Google Shape;308;p46"/>
+          <p:cNvPr id="309" name="Google Shape;309;p46"/>
           <p:cNvSpPr txBox="1"/>
           <p:nvPr>
             <p:ph type="title"/>
@@ -19249,7 +19396,7 @@
       </p:sp>
       <p:sp>
         <p:nvSpPr>
-          <p:cNvPr id="309" name="Google Shape;309;p46"/>
+          <p:cNvPr id="310" name="Google Shape;310;p46"/>
           <p:cNvSpPr txBox="1"/>
           <p:nvPr>
             <p:ph idx="12" type="sldNum"/>
@@ -19640,7 +19787,7 @@
   <p:cSld>
     <p:spTree>
       <p:nvGrpSpPr>
-        <p:cNvPr id="313" name="Shape 313"/>
+        <p:cNvPr id="314" name="Shape 314"/>
         <p:cNvGrpSpPr/>
         <p:nvPr/>
       </p:nvGrpSpPr>
@@ -19654,7 +19801,7 @@
       </p:grpSpPr>
       <p:sp>
         <p:nvSpPr>
-          <p:cNvPr id="314" name="Google Shape;314;p47"/>
+          <p:cNvPr id="315" name="Google Shape;315;p47"/>
           <p:cNvSpPr txBox="1"/>
           <p:nvPr>
             <p:ph type="title"/>
@@ -19694,7 +19841,7 @@
       </p:sp>
       <p:sp>
         <p:nvSpPr>
-          <p:cNvPr id="315" name="Google Shape;315;p47"/>
+          <p:cNvPr id="316" name="Google Shape;316;p47"/>
           <p:cNvSpPr txBox="1"/>
           <p:nvPr>
             <p:ph idx="12" type="sldNum"/>
@@ -19759,7 +19906,7 @@
       </p:sp>
       <p:sp>
         <p:nvSpPr>
-          <p:cNvPr id="316" name="Google Shape;316;p47"/>
+          <p:cNvPr id="317" name="Google Shape;317;p47"/>
           <p:cNvSpPr txBox="1"/>
           <p:nvPr>
             <p:ph idx="1" type="body"/>
@@ -19883,7 +20030,7 @@
       </p:sp>
       <p:sp>
         <p:nvSpPr>
-          <p:cNvPr id="317" name="Google Shape;317;p47"/>
+          <p:cNvPr id="318" name="Google Shape;318;p47"/>
           <p:cNvSpPr txBox="1"/>
           <p:nvPr/>
         </p:nvSpPr>
@@ -19955,7 +20102,7 @@
   <p:cSld>
     <p:spTree>
       <p:nvGrpSpPr>
-        <p:cNvPr id="321" name="Shape 321"/>
+        <p:cNvPr id="322" name="Shape 322"/>
         <p:cNvGrpSpPr/>
         <p:nvPr/>
       </p:nvGrpSpPr>
@@ -19969,7 +20116,7 @@
       </p:grpSpPr>
       <p:sp>
         <p:nvSpPr>
-          <p:cNvPr id="322" name="Google Shape;322;p48"/>
+          <p:cNvPr id="323" name="Google Shape;323;p48"/>
           <p:cNvSpPr txBox="1"/>
           <p:nvPr>
             <p:ph type="title"/>
@@ -20009,7 +20156,7 @@
       </p:sp>
       <p:sp>
         <p:nvSpPr>
-          <p:cNvPr id="323" name="Google Shape;323;p48"/>
+          <p:cNvPr id="324" name="Google Shape;324;p48"/>
           <p:cNvSpPr txBox="1"/>
           <p:nvPr>
             <p:ph idx="12" type="sldNum"/>
@@ -20074,7 +20221,7 @@
       </p:sp>
       <p:sp>
         <p:nvSpPr>
-          <p:cNvPr id="324" name="Google Shape;324;p48"/>
+          <p:cNvPr id="325" name="Google Shape;325;p48"/>
           <p:cNvSpPr txBox="1"/>
           <p:nvPr>
             <p:ph idx="1" type="body"/>
@@ -20175,7 +20322,7 @@
   <p:cSld>
     <p:spTree>
       <p:nvGrpSpPr>
-        <p:cNvPr id="328" name="Shape 328"/>
+        <p:cNvPr id="329" name="Shape 329"/>
         <p:cNvGrpSpPr/>
         <p:nvPr/>
       </p:nvGrpSpPr>
@@ -20189,7 +20336,7 @@
       </p:grpSpPr>
       <p:sp>
         <p:nvSpPr>
-          <p:cNvPr id="329" name="Google Shape;329;p49"/>
+          <p:cNvPr id="330" name="Google Shape;330;p49"/>
           <p:cNvSpPr txBox="1"/>
           <p:nvPr>
             <p:ph type="title"/>
@@ -20229,7 +20376,7 @@
       </p:sp>
       <p:sp>
         <p:nvSpPr>
-          <p:cNvPr id="330" name="Google Shape;330;p49"/>
+          <p:cNvPr id="331" name="Google Shape;331;p49"/>
           <p:cNvSpPr txBox="1"/>
           <p:nvPr>
             <p:ph idx="1" type="body"/>
@@ -20335,7 +20482,7 @@
       </p:sp>
       <p:sp>
         <p:nvSpPr>
-          <p:cNvPr id="331" name="Google Shape;331;p49"/>
+          <p:cNvPr id="332" name="Google Shape;332;p49"/>
           <p:cNvSpPr txBox="1"/>
           <p:nvPr>
             <p:ph idx="12" type="sldNum"/>
@@ -20411,7 +20558,7 @@
   <p:cSld>
     <p:spTree>
       <p:nvGrpSpPr>
-        <p:cNvPr id="335" name="Shape 335"/>
+        <p:cNvPr id="336" name="Shape 336"/>
         <p:cNvGrpSpPr/>
         <p:nvPr/>
       </p:nvGrpSpPr>
@@ -20425,7 +20572,7 @@
       </p:grpSpPr>
       <p:sp>
         <p:nvSpPr>
-          <p:cNvPr id="336" name="Google Shape;336;p50"/>
+          <p:cNvPr id="337" name="Google Shape;337;p50"/>
           <p:cNvSpPr txBox="1"/>
           <p:nvPr>
             <p:ph type="title"/>
@@ -20465,7 +20612,7 @@
       </p:sp>
       <p:sp>
         <p:nvSpPr>
-          <p:cNvPr id="337" name="Google Shape;337;p50"/>
+          <p:cNvPr id="338" name="Google Shape;338;p50"/>
           <p:cNvSpPr txBox="1"/>
           <p:nvPr>
             <p:ph idx="1" type="body"/>
@@ -20602,7 +20749,7 @@
       </p:sp>
       <p:sp>
         <p:nvSpPr>
-          <p:cNvPr id="338" name="Google Shape;338;p50"/>
+          <p:cNvPr id="339" name="Google Shape;339;p50"/>
           <p:cNvSpPr txBox="1"/>
           <p:nvPr>
             <p:ph idx="12" type="sldNum"/>
@@ -20678,7 +20825,7 @@
   <p:cSld>
     <p:spTree>
       <p:nvGrpSpPr>
-        <p:cNvPr id="342" name="Shape 342"/>
+        <p:cNvPr id="343" name="Shape 343"/>
         <p:cNvGrpSpPr/>
         <p:nvPr/>
       </p:nvGrpSpPr>
@@ -20692,7 +20839,7 @@
       </p:grpSpPr>
       <p:sp>
         <p:nvSpPr>
-          <p:cNvPr id="343" name="Google Shape;343;p51"/>
+          <p:cNvPr id="344" name="Google Shape;344;p51"/>
           <p:cNvSpPr txBox="1"/>
           <p:nvPr>
             <p:ph type="title"/>
@@ -20732,7 +20879,7 @@
       </p:sp>
       <p:sp>
         <p:nvSpPr>
-          <p:cNvPr id="344" name="Google Shape;344;p51"/>
+          <p:cNvPr id="345" name="Google Shape;345;p51"/>
           <p:cNvSpPr txBox="1"/>
           <p:nvPr>
             <p:ph idx="12" type="sldNum"/>
@@ -20797,7 +20944,7 @@
       </p:sp>
       <p:sp>
         <p:nvSpPr>
-          <p:cNvPr id="345" name="Google Shape;345;p51"/>
+          <p:cNvPr id="346" name="Google Shape;346;p51"/>
           <p:cNvSpPr txBox="1"/>
           <p:nvPr>
             <p:ph idx="1" type="body"/>
@@ -20846,7 +20993,7 @@
             </a:pPr>
             <a:r>
               <a:rPr lang="en"/>
-              <a:t>Theoretical saturation</a:t>
+              <a:t>Theory saturation</a:t>
             </a:r>
             <a:endParaRPr/>
           </a:p>
@@ -20898,7 +21045,7 @@
   <p:cSld>
     <p:spTree>
       <p:nvGrpSpPr>
-        <p:cNvPr id="349" name="Shape 349"/>
+        <p:cNvPr id="350" name="Shape 350"/>
         <p:cNvGrpSpPr/>
         <p:nvPr/>
       </p:nvGrpSpPr>
@@ -20912,7 +21059,7 @@
       </p:grpSpPr>
       <p:sp>
         <p:nvSpPr>
-          <p:cNvPr id="350" name="Google Shape;350;p52"/>
+          <p:cNvPr id="351" name="Google Shape;351;p52"/>
           <p:cNvSpPr txBox="1"/>
           <p:nvPr>
             <p:ph type="title"/>
@@ -20952,7 +21099,7 @@
       </p:sp>
       <p:sp>
         <p:nvSpPr>
-          <p:cNvPr id="351" name="Google Shape;351;p52"/>
+          <p:cNvPr id="352" name="Google Shape;352;p52"/>
           <p:cNvSpPr txBox="1"/>
           <p:nvPr>
             <p:ph idx="12" type="sldNum"/>
@@ -21017,7 +21164,7 @@
       </p:sp>
       <p:sp>
         <p:nvSpPr>
-          <p:cNvPr id="352" name="Google Shape;352;p52"/>
+          <p:cNvPr id="353" name="Google Shape;353;p52"/>
           <p:cNvSpPr txBox="1"/>
           <p:nvPr>
             <p:ph idx="1" type="body"/>
@@ -21140,7 +21287,7 @@
       </p:sp>
       <p:sp>
         <p:nvSpPr>
-          <p:cNvPr id="353" name="Google Shape;353;p52"/>
+          <p:cNvPr id="354" name="Google Shape;354;p52"/>
           <p:cNvSpPr txBox="1"/>
           <p:nvPr/>
         </p:nvSpPr>
@@ -21158,7 +21305,7 @@
           </a:ln>
         </p:spPr>
         <p:txBody>
-          <a:bodyPr anchorCtr="0" anchor="t" bIns="91425" lIns="91425" spcFirstLastPara="1" rIns="91425" wrap="square" tIns="91425">
+          <a:bodyPr anchorCtr="0" anchor="b" bIns="91425" lIns="91425" spcFirstLastPara="1" rIns="91425" wrap="square" tIns="91425">
             <a:noAutofit/>
           </a:bodyPr>
           <a:lstStyle/>
@@ -21197,7 +21344,7 @@
   <p:cSld>
     <p:spTree>
       <p:nvGrpSpPr>
-        <p:cNvPr id="357" name="Shape 357"/>
+        <p:cNvPr id="358" name="Shape 358"/>
         <p:cNvGrpSpPr/>
         <p:nvPr/>
       </p:nvGrpSpPr>
@@ -21211,7 +21358,7 @@
       </p:grpSpPr>
       <p:sp>
         <p:nvSpPr>
-          <p:cNvPr id="358" name="Google Shape;358;p53"/>
+          <p:cNvPr id="359" name="Google Shape;359;p53"/>
           <p:cNvSpPr txBox="1"/>
           <p:nvPr>
             <p:ph type="title"/>
@@ -21251,7 +21398,7 @@
       </p:sp>
       <p:sp>
         <p:nvSpPr>
-          <p:cNvPr id="359" name="Google Shape;359;p53"/>
+          <p:cNvPr id="360" name="Google Shape;360;p53"/>
           <p:cNvSpPr txBox="1"/>
           <p:nvPr>
             <p:ph idx="12" type="sldNum"/>
@@ -21316,7 +21463,7 @@
       </p:sp>
       <p:pic>
         <p:nvPicPr>
-          <p:cNvPr id="360" name="Google Shape;360;p53"/>
+          <p:cNvPr id="361" name="Google Shape;361;p53"/>
           <p:cNvPicPr preferRelativeResize="0"/>
           <p:nvPr/>
         </p:nvPicPr>
@@ -21355,7 +21502,7 @@
   <p:cSld>
     <p:spTree>
       <p:nvGrpSpPr>
-        <p:cNvPr id="364" name="Shape 364"/>
+        <p:cNvPr id="365" name="Shape 365"/>
         <p:cNvGrpSpPr/>
         <p:nvPr/>
       </p:nvGrpSpPr>
@@ -21369,7 +21516,7 @@
       </p:grpSpPr>
       <p:sp>
         <p:nvSpPr>
-          <p:cNvPr id="365" name="Google Shape;365;p54"/>
+          <p:cNvPr id="366" name="Google Shape;366;p54"/>
           <p:cNvSpPr txBox="1"/>
           <p:nvPr>
             <p:ph type="title"/>
@@ -21409,7 +21556,7 @@
       </p:sp>
       <p:sp>
         <p:nvSpPr>
-          <p:cNvPr id="366" name="Google Shape;366;p54"/>
+          <p:cNvPr id="367" name="Google Shape;367;p54"/>
           <p:cNvSpPr txBox="1"/>
           <p:nvPr>
             <p:ph idx="12" type="sldNum"/>
@@ -21474,7 +21621,7 @@
       </p:sp>
       <p:sp>
         <p:nvSpPr>
-          <p:cNvPr id="367" name="Google Shape;367;p54"/>
+          <p:cNvPr id="368" name="Google Shape;368;p54"/>
           <p:cNvSpPr txBox="1"/>
           <p:nvPr>
             <p:ph idx="1" type="body"/>
@@ -21523,7 +21670,7 @@
             </a:pPr>
             <a:r>
               <a:rPr lang="en"/>
-              <a:t>Use theoretical sampling to seek out new data</a:t>
+              <a:t>Use purposive sampling to seek out new data</a:t>
             </a:r>
             <a:endParaRPr/>
           </a:p>
@@ -21608,7 +21755,7 @@
   <p:cSld>
     <p:spTree>
       <p:nvGrpSpPr>
-        <p:cNvPr id="371" name="Shape 371"/>
+        <p:cNvPr id="372" name="Shape 372"/>
         <p:cNvGrpSpPr/>
         <p:nvPr/>
       </p:nvGrpSpPr>
@@ -21622,7 +21769,7 @@
       </p:grpSpPr>
       <p:sp>
         <p:nvSpPr>
-          <p:cNvPr id="372" name="Google Shape;372;p55"/>
+          <p:cNvPr id="373" name="Google Shape;373;p55"/>
           <p:cNvSpPr txBox="1"/>
           <p:nvPr>
             <p:ph type="title"/>
@@ -21662,7 +21809,7 @@
       </p:sp>
       <p:sp>
         <p:nvSpPr>
-          <p:cNvPr id="373" name="Google Shape;373;p55"/>
+          <p:cNvPr id="374" name="Google Shape;374;p55"/>
           <p:cNvSpPr txBox="1"/>
           <p:nvPr>
             <p:ph idx="12" type="sldNum"/>
@@ -21727,7 +21874,7 @@
       </p:sp>
       <p:pic>
         <p:nvPicPr>
-          <p:cNvPr id="374" name="Google Shape;374;p55"/>
+          <p:cNvPr id="375" name="Google Shape;375;p55"/>
           <p:cNvPicPr preferRelativeResize="0"/>
           <p:nvPr/>
         </p:nvPicPr>
@@ -21766,7 +21913,7 @@
   <p:cSld>
     <p:spTree>
       <p:nvGrpSpPr>
-        <p:cNvPr id="378" name="Shape 378"/>
+        <p:cNvPr id="379" name="Shape 379"/>
         <p:cNvGrpSpPr/>
         <p:nvPr/>
       </p:nvGrpSpPr>
@@ -21780,7 +21927,7 @@
       </p:grpSpPr>
       <p:sp>
         <p:nvSpPr>
-          <p:cNvPr id="379" name="Google Shape;379;p56"/>
+          <p:cNvPr id="380" name="Google Shape;380;p56"/>
           <p:cNvSpPr txBox="1"/>
           <p:nvPr>
             <p:ph type="title"/>
@@ -21820,7 +21967,7 @@
       </p:sp>
       <p:sp>
         <p:nvSpPr>
-          <p:cNvPr id="380" name="Google Shape;380;p56"/>
+          <p:cNvPr id="381" name="Google Shape;381;p56"/>
           <p:cNvSpPr txBox="1"/>
           <p:nvPr>
             <p:ph idx="12" type="sldNum"/>
@@ -21885,7 +22032,7 @@
       </p:sp>
       <p:sp>
         <p:nvSpPr>
-          <p:cNvPr id="381" name="Google Shape;381;p56"/>
+          <p:cNvPr id="382" name="Google Shape;382;p56"/>
           <p:cNvSpPr txBox="1"/>
           <p:nvPr>
             <p:ph idx="1" type="body"/>
@@ -22178,7 +22325,7 @@
   <p:cSld>
     <p:spTree>
       <p:nvGrpSpPr>
-        <p:cNvPr id="385" name="Shape 385"/>
+        <p:cNvPr id="386" name="Shape 386"/>
         <p:cNvGrpSpPr/>
         <p:nvPr/>
       </p:nvGrpSpPr>
@@ -22192,7 +22339,7 @@
       </p:grpSpPr>
       <p:sp>
         <p:nvSpPr>
-          <p:cNvPr id="386" name="Google Shape;386;p57"/>
+          <p:cNvPr id="387" name="Google Shape;387;p57"/>
           <p:cNvSpPr txBox="1"/>
           <p:nvPr>
             <p:ph type="title"/>
@@ -22232,7 +22379,7 @@
       </p:sp>
       <p:sp>
         <p:nvSpPr>
-          <p:cNvPr id="387" name="Google Shape;387;p57"/>
+          <p:cNvPr id="388" name="Google Shape;388;p57"/>
           <p:cNvSpPr txBox="1"/>
           <p:nvPr>
             <p:ph idx="1" type="body"/>
@@ -22346,7 +22493,7 @@
       </p:sp>
       <p:sp>
         <p:nvSpPr>
-          <p:cNvPr id="388" name="Google Shape;388;p57"/>
+          <p:cNvPr id="389" name="Google Shape;389;p57"/>
           <p:cNvSpPr txBox="1"/>
           <p:nvPr>
             <p:ph idx="12" type="sldNum"/>
@@ -22422,7 +22569,7 @@
   <p:cSld>
     <p:spTree>
       <p:nvGrpSpPr>
-        <p:cNvPr id="392" name="Shape 392"/>
+        <p:cNvPr id="393" name="Shape 393"/>
         <p:cNvGrpSpPr/>
         <p:nvPr/>
       </p:nvGrpSpPr>
@@ -22436,7 +22583,7 @@
       </p:grpSpPr>
       <p:sp>
         <p:nvSpPr>
-          <p:cNvPr id="393" name="Google Shape;393;p58"/>
+          <p:cNvPr id="394" name="Google Shape;394;p58"/>
           <p:cNvSpPr txBox="1"/>
           <p:nvPr>
             <p:ph type="title"/>
@@ -22476,7 +22623,7 @@
       </p:sp>
       <p:sp>
         <p:nvSpPr>
-          <p:cNvPr id="394" name="Google Shape;394;p58"/>
+          <p:cNvPr id="395" name="Google Shape;395;p58"/>
           <p:cNvSpPr txBox="1"/>
           <p:nvPr>
             <p:ph idx="12" type="sldNum"/>
@@ -22541,7 +22688,7 @@
       </p:sp>
       <p:pic>
         <p:nvPicPr>
-          <p:cNvPr id="395" name="Google Shape;395;p58"/>
+          <p:cNvPr id="396" name="Google Shape;396;p58"/>
           <p:cNvPicPr preferRelativeResize="0"/>
           <p:nvPr/>
         </p:nvPicPr>
@@ -22580,7 +22727,7 @@
   <p:cSld>
     <p:spTree>
       <p:nvGrpSpPr>
-        <p:cNvPr id="399" name="Shape 399"/>
+        <p:cNvPr id="400" name="Shape 400"/>
         <p:cNvGrpSpPr/>
         <p:nvPr/>
       </p:nvGrpSpPr>
@@ -22594,7 +22741,7 @@
       </p:grpSpPr>
       <p:sp>
         <p:nvSpPr>
-          <p:cNvPr id="400" name="Google Shape;400;p59"/>
+          <p:cNvPr id="401" name="Google Shape;401;p59"/>
           <p:cNvSpPr txBox="1"/>
           <p:nvPr>
             <p:ph type="title"/>
@@ -22634,7 +22781,7 @@
       </p:sp>
       <p:sp>
         <p:nvSpPr>
-          <p:cNvPr id="401" name="Google Shape;401;p59"/>
+          <p:cNvPr id="402" name="Google Shape;402;p59"/>
           <p:cNvSpPr txBox="1"/>
           <p:nvPr>
             <p:ph idx="12" type="sldNum"/>
@@ -22710,7 +22857,7 @@
   <p:cSld>
     <p:spTree>
       <p:nvGrpSpPr>
-        <p:cNvPr id="405" name="Shape 405"/>
+        <p:cNvPr id="406" name="Shape 406"/>
         <p:cNvGrpSpPr/>
         <p:nvPr/>
       </p:nvGrpSpPr>
@@ -22724,7 +22871,7 @@
       </p:grpSpPr>
       <p:sp>
         <p:nvSpPr>
-          <p:cNvPr id="406" name="Google Shape;406;p60"/>
+          <p:cNvPr id="407" name="Google Shape;407;p60"/>
           <p:cNvSpPr txBox="1"/>
           <p:nvPr>
             <p:ph type="title"/>
@@ -22764,7 +22911,7 @@
       </p:sp>
       <p:sp>
         <p:nvSpPr>
-          <p:cNvPr id="407" name="Google Shape;407;p60"/>
+          <p:cNvPr id="408" name="Google Shape;408;p60"/>
           <p:cNvSpPr txBox="1"/>
           <p:nvPr>
             <p:ph idx="12" type="sldNum"/>
@@ -22829,7 +22976,7 @@
       </p:sp>
       <p:sp>
         <p:nvSpPr>
-          <p:cNvPr id="408" name="Google Shape;408;p60"/>
+          <p:cNvPr id="409" name="Google Shape;409;p60"/>
           <p:cNvSpPr txBox="1"/>
           <p:nvPr>
             <p:ph idx="1" type="body"/>
@@ -22952,7 +23099,7 @@
   <p:cSld>
     <p:spTree>
       <p:nvGrpSpPr>
-        <p:cNvPr id="412" name="Shape 412"/>
+        <p:cNvPr id="413" name="Shape 413"/>
         <p:cNvGrpSpPr/>
         <p:nvPr/>
       </p:nvGrpSpPr>
@@ -22966,7 +23113,7 @@
       </p:grpSpPr>
       <p:sp>
         <p:nvSpPr>
-          <p:cNvPr id="413" name="Google Shape;413;p61"/>
+          <p:cNvPr id="414" name="Google Shape;414;p61"/>
           <p:cNvSpPr txBox="1"/>
           <p:nvPr>
             <p:ph type="title"/>
@@ -23006,7 +23153,7 @@
       </p:sp>
       <p:sp>
         <p:nvSpPr>
-          <p:cNvPr id="414" name="Google Shape;414;p61"/>
+          <p:cNvPr id="415" name="Google Shape;415;p61"/>
           <p:cNvSpPr txBox="1"/>
           <p:nvPr>
             <p:ph idx="1" type="body"/>
@@ -23072,7 +23219,7 @@
             </a:pPr>
             <a:r>
               <a:rPr lang="en"/>
-              <a:t>Stopping criterion is theoretical saturation</a:t>
+              <a:t>Stopping criterion is theory saturation</a:t>
             </a:r>
             <a:endParaRPr/>
           </a:p>
@@ -23130,7 +23277,7 @@
       </p:sp>
       <p:sp>
         <p:nvSpPr>
-          <p:cNvPr id="415" name="Google Shape;415;p61"/>
+          <p:cNvPr id="416" name="Google Shape;416;p61"/>
           <p:cNvSpPr txBox="1"/>
           <p:nvPr>
             <p:ph idx="12" type="sldNum"/>
@@ -23206,7 +23353,7 @@
   <p:cSld>
     <p:spTree>
       <p:nvGrpSpPr>
-        <p:cNvPr id="419" name="Shape 419"/>
+        <p:cNvPr id="420" name="Shape 420"/>
         <p:cNvGrpSpPr/>
         <p:nvPr/>
       </p:nvGrpSpPr>
@@ -23220,7 +23367,7 @@
       </p:grpSpPr>
       <p:sp>
         <p:nvSpPr>
-          <p:cNvPr id="420" name="Google Shape;420;p62"/>
+          <p:cNvPr id="421" name="Google Shape;421;p62"/>
           <p:cNvSpPr txBox="1"/>
           <p:nvPr>
             <p:ph idx="1" type="body"/>
@@ -23395,7 +23542,7 @@
       </p:sp>
       <p:sp>
         <p:nvSpPr>
-          <p:cNvPr id="421" name="Google Shape;421;p62"/>
+          <p:cNvPr id="422" name="Google Shape;422;p62"/>
           <p:cNvSpPr txBox="1"/>
           <p:nvPr>
             <p:ph type="title"/>
@@ -23435,7 +23582,7 @@
       </p:sp>
       <p:sp>
         <p:nvSpPr>
-          <p:cNvPr id="422" name="Google Shape;422;p62"/>
+          <p:cNvPr id="423" name="Google Shape;423;p62"/>
           <p:cNvSpPr txBox="1"/>
           <p:nvPr>
             <p:ph idx="12" type="sldNum"/>
@@ -23511,7 +23658,7 @@
   <p:cSld>
     <p:spTree>
       <p:nvGrpSpPr>
-        <p:cNvPr id="426" name="Shape 426"/>
+        <p:cNvPr id="427" name="Shape 427"/>
         <p:cNvGrpSpPr/>
         <p:nvPr/>
       </p:nvGrpSpPr>
@@ -23525,7 +23672,7 @@
       </p:grpSpPr>
       <p:sp>
         <p:nvSpPr>
-          <p:cNvPr id="427" name="Google Shape;427;p63"/>
+          <p:cNvPr id="428" name="Google Shape;428;p63"/>
           <p:cNvSpPr txBox="1"/>
           <p:nvPr>
             <p:ph type="title"/>
@@ -23565,7 +23712,7 @@
       </p:sp>
       <p:sp>
         <p:nvSpPr>
-          <p:cNvPr id="428" name="Google Shape;428;p63"/>
+          <p:cNvPr id="429" name="Google Shape;429;p63"/>
           <p:cNvSpPr txBox="1"/>
           <p:nvPr>
             <p:ph idx="12" type="sldNum"/>
@@ -23641,7 +23788,7 @@
   <p:cSld>
     <p:spTree>
       <p:nvGrpSpPr>
-        <p:cNvPr id="432" name="Shape 432"/>
+        <p:cNvPr id="433" name="Shape 433"/>
         <p:cNvGrpSpPr/>
         <p:nvPr/>
       </p:nvGrpSpPr>
@@ -23655,7 +23802,7 @@
       </p:grpSpPr>
       <p:sp>
         <p:nvSpPr>
-          <p:cNvPr id="433" name="Google Shape;433;p64"/>
+          <p:cNvPr id="434" name="Google Shape;434;p64"/>
           <p:cNvSpPr txBox="1"/>
           <p:nvPr>
             <p:ph type="title"/>
@@ -23695,7 +23842,7 @@
       </p:sp>
       <p:sp>
         <p:nvSpPr>
-          <p:cNvPr id="434" name="Google Shape;434;p64"/>
+          <p:cNvPr id="435" name="Google Shape;435;p64"/>
           <p:cNvSpPr txBox="1"/>
           <p:nvPr>
             <p:ph idx="12" type="sldNum"/>
@@ -23760,7 +23907,7 @@
       </p:sp>
       <p:sp>
         <p:nvSpPr>
-          <p:cNvPr id="435" name="Google Shape;435;p64"/>
+          <p:cNvPr id="436" name="Google Shape;436;p64"/>
           <p:cNvSpPr txBox="1"/>
           <p:nvPr>
             <p:ph idx="1" type="body"/>
@@ -23852,7 +23999,7 @@
       </p:sp>
       <p:sp>
         <p:nvSpPr>
-          <p:cNvPr id="436" name="Google Shape;436;p64"/>
+          <p:cNvPr id="437" name="Google Shape;437;p64"/>
           <p:cNvSpPr txBox="1"/>
           <p:nvPr/>
         </p:nvSpPr>
@@ -23976,7 +24123,7 @@
   <p:cSld>
     <p:spTree>
       <p:nvGrpSpPr>
-        <p:cNvPr id="440" name="Shape 440"/>
+        <p:cNvPr id="441" name="Shape 441"/>
         <p:cNvGrpSpPr/>
         <p:nvPr/>
       </p:nvGrpSpPr>
@@ -23990,7 +24137,7 @@
       </p:grpSpPr>
       <p:sp>
         <p:nvSpPr>
-          <p:cNvPr id="441" name="Google Shape;441;p65"/>
+          <p:cNvPr id="442" name="Google Shape;442;p65"/>
           <p:cNvSpPr txBox="1"/>
           <p:nvPr>
             <p:ph idx="1" type="body"/>
@@ -24023,7 +24170,7 @@
             </a:pPr>
             <a:r>
               <a:rPr lang="en"/>
-              <a:t>Theory building</a:t>
+              <a:t>QDA in theory building</a:t>
             </a:r>
             <a:endParaRPr/>
           </a:p>
@@ -24040,7 +24187,7 @@
             </a:pPr>
             <a:r>
               <a:rPr lang="en"/>
-              <a:t>QDA methods</a:t>
+              <a:t>QDA artifacts</a:t>
             </a:r>
             <a:endParaRPr/>
           </a:p>
@@ -24057,7 +24204,7 @@
             </a:pPr>
             <a:r>
               <a:rPr lang="en"/>
-              <a:t>QDA artifacts</a:t>
+              <a:t>QDA methods</a:t>
             </a:r>
             <a:endParaRPr/>
           </a:p>
@@ -24133,7 +24280,7 @@
       </p:sp>
       <p:sp>
         <p:nvSpPr>
-          <p:cNvPr id="442" name="Google Shape;442;p65"/>
+          <p:cNvPr id="443" name="Google Shape;443;p65"/>
           <p:cNvSpPr txBox="1"/>
           <p:nvPr>
             <p:ph type="title"/>
@@ -24173,7 +24320,7 @@
       </p:sp>
       <p:sp>
         <p:nvSpPr>
-          <p:cNvPr id="443" name="Google Shape;443;p65"/>
+          <p:cNvPr id="444" name="Google Shape;444;p65"/>
           <p:cNvSpPr txBox="1"/>
           <p:nvPr>
             <p:ph idx="12" type="sldNum"/>
@@ -24249,7 +24396,7 @@
   <p:cSld>
     <p:spTree>
       <p:nvGrpSpPr>
-        <p:cNvPr id="447" name="Shape 447"/>
+        <p:cNvPr id="448" name="Shape 448"/>
         <p:cNvGrpSpPr/>
         <p:nvPr/>
       </p:nvGrpSpPr>
@@ -24263,7 +24410,7 @@
       </p:grpSpPr>
       <p:sp>
         <p:nvSpPr>
-          <p:cNvPr id="448" name="Google Shape;448;p66"/>
+          <p:cNvPr id="449" name="Google Shape;449;p66"/>
           <p:cNvSpPr txBox="1"/>
           <p:nvPr>
             <p:ph type="ctrTitle"/>
@@ -24303,7 +24450,7 @@
       </p:sp>
       <p:sp>
         <p:nvSpPr>
-          <p:cNvPr id="449" name="Google Shape;449;p66"/>
+          <p:cNvPr id="450" name="Google Shape;450;p66"/>
           <p:cNvSpPr txBox="1"/>
           <p:nvPr>
             <p:ph idx="1" type="subTitle"/>
@@ -24690,7 +24837,7 @@
   <p:cSld>
     <p:spTree>
       <p:nvGrpSpPr>
-        <p:cNvPr id="453" name="Shape 453"/>
+        <p:cNvPr id="454" name="Shape 454"/>
         <p:cNvGrpSpPr/>
         <p:nvPr/>
       </p:nvGrpSpPr>
@@ -24704,7 +24851,7 @@
       </p:grpSpPr>
       <p:sp>
         <p:nvSpPr>
-          <p:cNvPr id="454" name="Google Shape;454;p67"/>
+          <p:cNvPr id="455" name="Google Shape;455;p67"/>
           <p:cNvSpPr txBox="1"/>
           <p:nvPr>
             <p:ph type="title"/>
@@ -24744,7 +24891,7 @@
       </p:sp>
       <p:sp>
         <p:nvSpPr>
-          <p:cNvPr id="455" name="Google Shape;455;p67"/>
+          <p:cNvPr id="456" name="Google Shape;456;p67"/>
           <p:cNvSpPr txBox="1"/>
           <p:nvPr>
             <p:ph idx="12" type="sldNum"/>
@@ -24809,7 +24956,7 @@
       </p:sp>
       <p:sp>
         <p:nvSpPr>
-          <p:cNvPr id="456" name="Google Shape;456;p67"/>
+          <p:cNvPr id="457" name="Google Shape;457;p67"/>
           <p:cNvSpPr txBox="1"/>
           <p:nvPr>
             <p:ph idx="1" type="body"/>

</xml_diff>

<commit_message>
More small fixes after QDA lecture
</commit_message>
<xml_diff>
--- a/Lecture slides/NYT B03 - Qualitative Data Analysis.pptx
+++ b/Lecture slides/NYT B03 - Qualitative Data Analysis.pptx
@@ -15246,7 +15246,7 @@
             <a:tbl>
               <a:tblPr>
                 <a:noFill/>
-                <a:tableStyleId>{BCD062AF-5B59-40DB-9C61-5F2C5996C835}</a:tableStyleId>
+                <a:tableStyleId>{70A4FFC3-DA45-4E75-927B-6269FA2CB669}</a:tableStyleId>
               </a:tblPr>
               <a:tblGrid>
                 <a:gridCol w="1719075"/>
@@ -25610,6 +25610,285 @@
 </file>
 
 <file path=ppt/theme/theme1.xml><?xml version="1.0" encoding="utf-8"?>
+<a:theme xmlns:a="http://schemas.openxmlformats.org/drawingml/2006/main" xmlns:r="http://schemas.openxmlformats.org/officeDocument/2006/relationships">
+  <a:themeElements>
+    <a:clrScheme name="Default">
+      <a:dk1>
+        <a:srgbClr val="000000"/>
+      </a:dk1>
+      <a:lt1>
+        <a:srgbClr val="FFFFFF"/>
+      </a:lt1>
+      <a:dk2>
+        <a:srgbClr val="158158"/>
+      </a:dk2>
+      <a:lt2>
+        <a:srgbClr val="F3F3F3"/>
+      </a:lt2>
+      <a:accent1>
+        <a:srgbClr val="058DC7"/>
+      </a:accent1>
+      <a:accent2>
+        <a:srgbClr val="50B432"/>
+      </a:accent2>
+      <a:accent3>
+        <a:srgbClr val="ED561B"/>
+      </a:accent3>
+      <a:accent4>
+        <a:srgbClr val="EDEF00"/>
+      </a:accent4>
+      <a:accent5>
+        <a:srgbClr val="24CBE5"/>
+      </a:accent5>
+      <a:accent6>
+        <a:srgbClr val="64E572"/>
+      </a:accent6>
+      <a:hlink>
+        <a:srgbClr val="2200CC"/>
+      </a:hlink>
+      <a:folHlink>
+        <a:srgbClr val="551A8B"/>
+      </a:folHlink>
+    </a:clrScheme>
+    <a:fontScheme name="Office">
+      <a:majorFont>
+        <a:latin typeface="Arial"/>
+        <a:ea typeface=""/>
+        <a:cs typeface=""/>
+        <a:font script="Jpan" typeface="ＭＳ Ｐゴシック"/>
+        <a:font script="Hang" typeface="맑은 고딕"/>
+        <a:font script="Hans" typeface="宋体"/>
+        <a:font script="Hant" typeface="新細明體"/>
+        <a:font script="Arab" typeface="Times New Roman"/>
+        <a:font script="Hebr" typeface="Times New Roman"/>
+        <a:font script="Thai" typeface="Angsana New"/>
+        <a:font script="Ethi" typeface="Nyala"/>
+        <a:font script="Beng" typeface="Vrinda"/>
+        <a:font script="Gujr" typeface="Shruti"/>
+        <a:font script="Khmr" typeface="MoolBoran"/>
+        <a:font script="Knda" typeface="Tunga"/>
+        <a:font script="Guru" typeface="Raavi"/>
+        <a:font script="Cans" typeface="Euphemia"/>
+        <a:font script="Cher" typeface="Plantagenet Cherokee"/>
+        <a:font script="Yiii" typeface="Microsoft Yi Baiti"/>
+        <a:font script="Tibt" typeface="Microsoft Himalaya"/>
+        <a:font script="Thaa" typeface="MV Boli"/>
+        <a:font script="Deva" typeface="Mangal"/>
+        <a:font script="Telu" typeface="Gautami"/>
+        <a:font script="Taml" typeface="Latha"/>
+        <a:font script="Syrc" typeface="Estrangelo Edessa"/>
+        <a:font script="Orya" typeface="Kalinga"/>
+        <a:font script="Mlym" typeface="Kartika"/>
+        <a:font script="Laoo" typeface="DokChampa"/>
+        <a:font script="Sinh" typeface="Iskoola Pota"/>
+        <a:font script="Mong" typeface="Mongolian Baiti"/>
+        <a:font script="Viet" typeface="Times New Roman"/>
+        <a:font script="Uigh" typeface="Microsoft Uighur"/>
+        <a:font script="Geor" typeface="Sylfaen"/>
+      </a:majorFont>
+      <a:minorFont>
+        <a:latin typeface="Arial"/>
+        <a:ea typeface=""/>
+        <a:cs typeface=""/>
+        <a:font script="Jpan" typeface="ＭＳ Ｐゴシック"/>
+        <a:font script="Hang" typeface="맑은 고딕"/>
+        <a:font script="Hans" typeface="宋体"/>
+        <a:font script="Hant" typeface="新細明體"/>
+        <a:font script="Arab" typeface="Arial"/>
+        <a:font script="Hebr" typeface="Arial"/>
+        <a:font script="Thai" typeface="Cordia New"/>
+        <a:font script="Ethi" typeface="Nyala"/>
+        <a:font script="Beng" typeface="Vrinda"/>
+        <a:font script="Gujr" typeface="Shruti"/>
+        <a:font script="Khmr" typeface="DaunPenh"/>
+        <a:font script="Knda" typeface="Tunga"/>
+        <a:font script="Guru" typeface="Raavi"/>
+        <a:font script="Cans" typeface="Euphemia"/>
+        <a:font script="Cher" typeface="Plantagenet Cherokee"/>
+        <a:font script="Yiii" typeface="Microsoft Yi Baiti"/>
+        <a:font script="Tibt" typeface="Microsoft Himalaya"/>
+        <a:font script="Thaa" typeface="MV Boli"/>
+        <a:font script="Deva" typeface="Mangal"/>
+        <a:font script="Telu" typeface="Gautami"/>
+        <a:font script="Taml" typeface="Latha"/>
+        <a:font script="Syrc" typeface="Estrangelo Edessa"/>
+        <a:font script="Orya" typeface="Kalinga"/>
+        <a:font script="Mlym" typeface="Kartika"/>
+        <a:font script="Laoo" typeface="DokChampa"/>
+        <a:font script="Sinh" typeface="Iskoola Pota"/>
+        <a:font script="Mong" typeface="Mongolian Baiti"/>
+        <a:font script="Viet" typeface="Arial"/>
+        <a:font script="Uigh" typeface="Microsoft Uighur"/>
+        <a:font script="Geor" typeface="Sylfaen"/>
+      </a:minorFont>
+    </a:fontScheme>
+    <a:fmtScheme name="Office">
+      <a:fillStyleLst>
+        <a:solidFill>
+          <a:schemeClr val="phClr"/>
+        </a:solidFill>
+        <a:gradFill rotWithShape="1">
+          <a:gsLst>
+            <a:gs pos="0">
+              <a:schemeClr val="phClr">
+                <a:tint val="50000"/>
+                <a:satMod val="300000"/>
+              </a:schemeClr>
+            </a:gs>
+            <a:gs pos="35000">
+              <a:schemeClr val="phClr">
+                <a:tint val="37000"/>
+                <a:satMod val="300000"/>
+              </a:schemeClr>
+            </a:gs>
+            <a:gs pos="100000">
+              <a:schemeClr val="phClr">
+                <a:tint val="15000"/>
+                <a:satMod val="350000"/>
+              </a:schemeClr>
+            </a:gs>
+          </a:gsLst>
+          <a:lin ang="16200000" scaled="1"/>
+        </a:gradFill>
+        <a:gradFill rotWithShape="1">
+          <a:gsLst>
+            <a:gs pos="0">
+              <a:schemeClr val="phClr">
+                <a:tint val="100000"/>
+                <a:shade val="100000"/>
+                <a:satMod val="130000"/>
+              </a:schemeClr>
+            </a:gs>
+            <a:gs pos="100000">
+              <a:schemeClr val="phClr">
+                <a:tint val="50000"/>
+                <a:shade val="100000"/>
+                <a:satMod val="350000"/>
+              </a:schemeClr>
+            </a:gs>
+          </a:gsLst>
+          <a:lin ang="16200000" scaled="0"/>
+        </a:gradFill>
+      </a:fillStyleLst>
+      <a:lnStyleLst>
+        <a:ln w="9525" cap="flat" cmpd="sng" algn="ctr">
+          <a:solidFill>
+            <a:schemeClr val="phClr">
+              <a:shade val="95000"/>
+              <a:satMod val="105000"/>
+            </a:schemeClr>
+          </a:solidFill>
+          <a:prstDash val="solid"/>
+        </a:ln>
+        <a:ln w="25400" cap="flat" cmpd="sng" algn="ctr">
+          <a:solidFill>
+            <a:schemeClr val="phClr"/>
+          </a:solidFill>
+          <a:prstDash val="solid"/>
+        </a:ln>
+        <a:ln w="38100" cap="flat" cmpd="sng" algn="ctr">
+          <a:solidFill>
+            <a:schemeClr val="phClr"/>
+          </a:solidFill>
+          <a:prstDash val="solid"/>
+        </a:ln>
+      </a:lnStyleLst>
+      <a:effectStyleLst>
+        <a:effectStyle>
+          <a:effectLst>
+            <a:outerShdw blurRad="40000" dist="20000" dir="5400000" rotWithShape="0">
+              <a:srgbClr val="000000">
+                <a:alpha val="38000"/>
+              </a:srgbClr>
+            </a:outerShdw>
+          </a:effectLst>
+        </a:effectStyle>
+        <a:effectStyle>
+          <a:effectLst>
+            <a:outerShdw blurRad="40000" dist="23000" dir="5400000" rotWithShape="0">
+              <a:srgbClr val="000000">
+                <a:alpha val="35000"/>
+              </a:srgbClr>
+            </a:outerShdw>
+          </a:effectLst>
+        </a:effectStyle>
+        <a:effectStyle>
+          <a:effectLst>
+            <a:outerShdw blurRad="40000" dist="23000" dir="5400000" rotWithShape="0">
+              <a:srgbClr val="000000">
+                <a:alpha val="35000"/>
+              </a:srgbClr>
+            </a:outerShdw>
+          </a:effectLst>
+          <a:scene3d>
+            <a:camera prst="orthographicFront">
+              <a:rot lat="0" lon="0" rev="0"/>
+            </a:camera>
+            <a:lightRig rig="threePt" dir="t">
+              <a:rot lat="0" lon="0" rev="1200000"/>
+            </a:lightRig>
+          </a:scene3d>
+          <a:sp3d>
+            <a:bevelT w="63500" h="25400"/>
+          </a:sp3d>
+        </a:effectStyle>
+      </a:effectStyleLst>
+      <a:bgFillStyleLst>
+        <a:solidFill>
+          <a:schemeClr val="phClr"/>
+        </a:solidFill>
+        <a:gradFill rotWithShape="1">
+          <a:gsLst>
+            <a:gs pos="0">
+              <a:schemeClr val="phClr">
+                <a:tint val="40000"/>
+                <a:satMod val="350000"/>
+              </a:schemeClr>
+            </a:gs>
+            <a:gs pos="40000">
+              <a:schemeClr val="phClr">
+                <a:tint val="45000"/>
+                <a:shade val="99000"/>
+                <a:satMod val="350000"/>
+              </a:schemeClr>
+            </a:gs>
+            <a:gs pos="100000">
+              <a:schemeClr val="phClr">
+                <a:shade val="20000"/>
+                <a:satMod val="255000"/>
+              </a:schemeClr>
+            </a:gs>
+          </a:gsLst>
+          <a:path path="circle">
+            <a:fillToRect l="50000" t="-80000" r="50000" b="180000"/>
+          </a:path>
+        </a:gradFill>
+        <a:gradFill rotWithShape="1">
+          <a:gsLst>
+            <a:gs pos="0">
+              <a:schemeClr val="phClr">
+                <a:tint val="80000"/>
+                <a:satMod val="300000"/>
+              </a:schemeClr>
+            </a:gs>
+            <a:gs pos="100000">
+              <a:schemeClr val="phClr">
+                <a:shade val="30000"/>
+                <a:satMod val="200000"/>
+              </a:schemeClr>
+            </a:gs>
+          </a:gsLst>
+          <a:path path="circle">
+            <a:fillToRect l="50000" t="50000" r="50000" b="50000"/>
+          </a:path>
+        </a:gradFill>
+      </a:bgFillStyleLst>
+    </a:fmtScheme>
+  </a:themeElements>
+</a:theme>
+</file>
+
+<file path=ppt/theme/theme2.xml><?xml version="1.0" encoding="utf-8"?>
 <a:theme xmlns:a="http://schemas.openxmlformats.org/drawingml/2006/main" xmlns:r="http://schemas.openxmlformats.org/officeDocument/2006/relationships" name="NYT Slides Template">
   <a:themeElements>
     <a:clrScheme name="Simple Light">
@@ -25886,283 +26165,4 @@
     </a:fmtScheme>
   </a:themeElements>
 </a:theme>
-</file>
-
-<file path=ppt/theme/theme2.xml><?xml version="1.0" encoding="utf-8"?>
-<a:theme xmlns:a="http://schemas.openxmlformats.org/drawingml/2006/main" xmlns:r="http://schemas.openxmlformats.org/officeDocument/2006/relationships">
-  <a:themeElements>
-    <a:clrScheme name="Default">
-      <a:dk1>
-        <a:srgbClr val="000000"/>
-      </a:dk1>
-      <a:lt1>
-        <a:srgbClr val="FFFFFF"/>
-      </a:lt1>
-      <a:dk2>
-        <a:srgbClr val="158158"/>
-      </a:dk2>
-      <a:lt2>
-        <a:srgbClr val="F3F3F3"/>
-      </a:lt2>
-      <a:accent1>
-        <a:srgbClr val="058DC7"/>
-      </a:accent1>
-      <a:accent2>
-        <a:srgbClr val="50B432"/>
-      </a:accent2>
-      <a:accent3>
-        <a:srgbClr val="ED561B"/>
-      </a:accent3>
-      <a:accent4>
-        <a:srgbClr val="EDEF00"/>
-      </a:accent4>
-      <a:accent5>
-        <a:srgbClr val="24CBE5"/>
-      </a:accent5>
-      <a:accent6>
-        <a:srgbClr val="64E572"/>
-      </a:accent6>
-      <a:hlink>
-        <a:srgbClr val="2200CC"/>
-      </a:hlink>
-      <a:folHlink>
-        <a:srgbClr val="551A8B"/>
-      </a:folHlink>
-    </a:clrScheme>
-    <a:fontScheme name="Office">
-      <a:majorFont>
-        <a:latin typeface="Arial"/>
-        <a:ea typeface=""/>
-        <a:cs typeface=""/>
-        <a:font script="Jpan" typeface="ＭＳ Ｐゴシック"/>
-        <a:font script="Hang" typeface="맑은 고딕"/>
-        <a:font script="Hans" typeface="宋体"/>
-        <a:font script="Hant" typeface="新細明體"/>
-        <a:font script="Arab" typeface="Times New Roman"/>
-        <a:font script="Hebr" typeface="Times New Roman"/>
-        <a:font script="Thai" typeface="Angsana New"/>
-        <a:font script="Ethi" typeface="Nyala"/>
-        <a:font script="Beng" typeface="Vrinda"/>
-        <a:font script="Gujr" typeface="Shruti"/>
-        <a:font script="Khmr" typeface="MoolBoran"/>
-        <a:font script="Knda" typeface="Tunga"/>
-        <a:font script="Guru" typeface="Raavi"/>
-        <a:font script="Cans" typeface="Euphemia"/>
-        <a:font script="Cher" typeface="Plantagenet Cherokee"/>
-        <a:font script="Yiii" typeface="Microsoft Yi Baiti"/>
-        <a:font script="Tibt" typeface="Microsoft Himalaya"/>
-        <a:font script="Thaa" typeface="MV Boli"/>
-        <a:font script="Deva" typeface="Mangal"/>
-        <a:font script="Telu" typeface="Gautami"/>
-        <a:font script="Taml" typeface="Latha"/>
-        <a:font script="Syrc" typeface="Estrangelo Edessa"/>
-        <a:font script="Orya" typeface="Kalinga"/>
-        <a:font script="Mlym" typeface="Kartika"/>
-        <a:font script="Laoo" typeface="DokChampa"/>
-        <a:font script="Sinh" typeface="Iskoola Pota"/>
-        <a:font script="Mong" typeface="Mongolian Baiti"/>
-        <a:font script="Viet" typeface="Times New Roman"/>
-        <a:font script="Uigh" typeface="Microsoft Uighur"/>
-        <a:font script="Geor" typeface="Sylfaen"/>
-      </a:majorFont>
-      <a:minorFont>
-        <a:latin typeface="Arial"/>
-        <a:ea typeface=""/>
-        <a:cs typeface=""/>
-        <a:font script="Jpan" typeface="ＭＳ Ｐゴシック"/>
-        <a:font script="Hang" typeface="맑은 고딕"/>
-        <a:font script="Hans" typeface="宋体"/>
-        <a:font script="Hant" typeface="新細明體"/>
-        <a:font script="Arab" typeface="Arial"/>
-        <a:font script="Hebr" typeface="Arial"/>
-        <a:font script="Thai" typeface="Cordia New"/>
-        <a:font script="Ethi" typeface="Nyala"/>
-        <a:font script="Beng" typeface="Vrinda"/>
-        <a:font script="Gujr" typeface="Shruti"/>
-        <a:font script="Khmr" typeface="DaunPenh"/>
-        <a:font script="Knda" typeface="Tunga"/>
-        <a:font script="Guru" typeface="Raavi"/>
-        <a:font script="Cans" typeface="Euphemia"/>
-        <a:font script="Cher" typeface="Plantagenet Cherokee"/>
-        <a:font script="Yiii" typeface="Microsoft Yi Baiti"/>
-        <a:font script="Tibt" typeface="Microsoft Himalaya"/>
-        <a:font script="Thaa" typeface="MV Boli"/>
-        <a:font script="Deva" typeface="Mangal"/>
-        <a:font script="Telu" typeface="Gautami"/>
-        <a:font script="Taml" typeface="Latha"/>
-        <a:font script="Syrc" typeface="Estrangelo Edessa"/>
-        <a:font script="Orya" typeface="Kalinga"/>
-        <a:font script="Mlym" typeface="Kartika"/>
-        <a:font script="Laoo" typeface="DokChampa"/>
-        <a:font script="Sinh" typeface="Iskoola Pota"/>
-        <a:font script="Mong" typeface="Mongolian Baiti"/>
-        <a:font script="Viet" typeface="Arial"/>
-        <a:font script="Uigh" typeface="Microsoft Uighur"/>
-        <a:font script="Geor" typeface="Sylfaen"/>
-      </a:minorFont>
-    </a:fontScheme>
-    <a:fmtScheme name="Office">
-      <a:fillStyleLst>
-        <a:solidFill>
-          <a:schemeClr val="phClr"/>
-        </a:solidFill>
-        <a:gradFill rotWithShape="1">
-          <a:gsLst>
-            <a:gs pos="0">
-              <a:schemeClr val="phClr">
-                <a:tint val="50000"/>
-                <a:satMod val="300000"/>
-              </a:schemeClr>
-            </a:gs>
-            <a:gs pos="35000">
-              <a:schemeClr val="phClr">
-                <a:tint val="37000"/>
-                <a:satMod val="300000"/>
-              </a:schemeClr>
-            </a:gs>
-            <a:gs pos="100000">
-              <a:schemeClr val="phClr">
-                <a:tint val="15000"/>
-                <a:satMod val="350000"/>
-              </a:schemeClr>
-            </a:gs>
-          </a:gsLst>
-          <a:lin ang="16200000" scaled="1"/>
-        </a:gradFill>
-        <a:gradFill rotWithShape="1">
-          <a:gsLst>
-            <a:gs pos="0">
-              <a:schemeClr val="phClr">
-                <a:tint val="100000"/>
-                <a:shade val="100000"/>
-                <a:satMod val="130000"/>
-              </a:schemeClr>
-            </a:gs>
-            <a:gs pos="100000">
-              <a:schemeClr val="phClr">
-                <a:tint val="50000"/>
-                <a:shade val="100000"/>
-                <a:satMod val="350000"/>
-              </a:schemeClr>
-            </a:gs>
-          </a:gsLst>
-          <a:lin ang="16200000" scaled="0"/>
-        </a:gradFill>
-      </a:fillStyleLst>
-      <a:lnStyleLst>
-        <a:ln w="9525" cap="flat" cmpd="sng" algn="ctr">
-          <a:solidFill>
-            <a:schemeClr val="phClr">
-              <a:shade val="95000"/>
-              <a:satMod val="105000"/>
-            </a:schemeClr>
-          </a:solidFill>
-          <a:prstDash val="solid"/>
-        </a:ln>
-        <a:ln w="25400" cap="flat" cmpd="sng" algn="ctr">
-          <a:solidFill>
-            <a:schemeClr val="phClr"/>
-          </a:solidFill>
-          <a:prstDash val="solid"/>
-        </a:ln>
-        <a:ln w="38100" cap="flat" cmpd="sng" algn="ctr">
-          <a:solidFill>
-            <a:schemeClr val="phClr"/>
-          </a:solidFill>
-          <a:prstDash val="solid"/>
-        </a:ln>
-      </a:lnStyleLst>
-      <a:effectStyleLst>
-        <a:effectStyle>
-          <a:effectLst>
-            <a:outerShdw blurRad="40000" dist="20000" dir="5400000" rotWithShape="0">
-              <a:srgbClr val="000000">
-                <a:alpha val="38000"/>
-              </a:srgbClr>
-            </a:outerShdw>
-          </a:effectLst>
-        </a:effectStyle>
-        <a:effectStyle>
-          <a:effectLst>
-            <a:outerShdw blurRad="40000" dist="23000" dir="5400000" rotWithShape="0">
-              <a:srgbClr val="000000">
-                <a:alpha val="35000"/>
-              </a:srgbClr>
-            </a:outerShdw>
-          </a:effectLst>
-        </a:effectStyle>
-        <a:effectStyle>
-          <a:effectLst>
-            <a:outerShdw blurRad="40000" dist="23000" dir="5400000" rotWithShape="0">
-              <a:srgbClr val="000000">
-                <a:alpha val="35000"/>
-              </a:srgbClr>
-            </a:outerShdw>
-          </a:effectLst>
-          <a:scene3d>
-            <a:camera prst="orthographicFront">
-              <a:rot lat="0" lon="0" rev="0"/>
-            </a:camera>
-            <a:lightRig rig="threePt" dir="t">
-              <a:rot lat="0" lon="0" rev="1200000"/>
-            </a:lightRig>
-          </a:scene3d>
-          <a:sp3d>
-            <a:bevelT w="63500" h="25400"/>
-          </a:sp3d>
-        </a:effectStyle>
-      </a:effectStyleLst>
-      <a:bgFillStyleLst>
-        <a:solidFill>
-          <a:schemeClr val="phClr"/>
-        </a:solidFill>
-        <a:gradFill rotWithShape="1">
-          <a:gsLst>
-            <a:gs pos="0">
-              <a:schemeClr val="phClr">
-                <a:tint val="40000"/>
-                <a:satMod val="350000"/>
-              </a:schemeClr>
-            </a:gs>
-            <a:gs pos="40000">
-              <a:schemeClr val="phClr">
-                <a:tint val="45000"/>
-                <a:shade val="99000"/>
-                <a:satMod val="350000"/>
-              </a:schemeClr>
-            </a:gs>
-            <a:gs pos="100000">
-              <a:schemeClr val="phClr">
-                <a:shade val="20000"/>
-                <a:satMod val="255000"/>
-              </a:schemeClr>
-            </a:gs>
-          </a:gsLst>
-          <a:path path="circle">
-            <a:fillToRect l="50000" t="-80000" r="50000" b="180000"/>
-          </a:path>
-        </a:gradFill>
-        <a:gradFill rotWithShape="1">
-          <a:gsLst>
-            <a:gs pos="0">
-              <a:schemeClr val="phClr">
-                <a:tint val="80000"/>
-                <a:satMod val="300000"/>
-              </a:schemeClr>
-            </a:gs>
-            <a:gs pos="100000">
-              <a:schemeClr val="phClr">
-                <a:shade val="30000"/>
-                <a:satMod val="200000"/>
-              </a:schemeClr>
-            </a:gs>
-          </a:gsLst>
-          <a:path path="circle">
-            <a:fillToRect l="50000" t="50000" r="50000" b="50000"/>
-          </a:path>
-        </a:gradFill>
-      </a:bgFillStyleLst>
-    </a:fmtScheme>
-  </a:themeElements>
-</a:theme>
 </file>
</xml_diff>